<commit_message>
ddl in präsentation eingefüt
</commit_message>
<xml_diff>
--- a/docs/Präsentation1803.pptx
+++ b/docs/Präsentation1803.pptx
@@ -109,6 +109,11 @@
       </a:defRPr>
     </a:lvl9pPr>
   </p:defaultTextStyle>
+  <p:extLst>
+    <p:ext uri="{EFAFB233-063F-42B5-8137-9DF3F51BA10A}">
+      <p15:sldGuideLst xmlns:p15="http://schemas.microsoft.com/office/powerpoint/2012/main"/>
+    </p:ext>
+  </p:extLst>
 </p:presentation>
 </file>
 
@@ -6368,6 +6373,267 @@
 </dgm:styleDef>
 </file>
 
+<file path=ppt/ink/ink1.xml><?xml version="1.0" encoding="utf-8"?>
+<inkml:ink xmlns:inkml="http://www.w3.org/2003/InkML">
+  <inkml:definitions>
+    <inkml:context xml:id="ctx0">
+      <inkml:inkSource xml:id="inkSrc0">
+        <inkml:traceFormat>
+          <inkml:channel name="X" type="integer" min="-2.14748E9" max="2.14748E9" units="cm"/>
+          <inkml:channel name="Y" type="integer" min="-2.14748E9" max="2.14748E9" units="cm"/>
+        </inkml:traceFormat>
+        <inkml:channelProperties>
+          <inkml:channelProperty channel="X" name="resolution" value="1000" units="1/cm"/>
+          <inkml:channelProperty channel="Y" name="resolution" value="1000" units="1/cm"/>
+        </inkml:channelProperties>
+      </inkml:inkSource>
+      <inkml:timestamp xml:id="ts0" timeString="2026-03-18T09:22:58.810"/>
+    </inkml:context>
+    <inkml:brush xml:id="br0">
+      <inkml:brushProperty name="width" value="0.3" units="cm"/>
+      <inkml:brushProperty name="height" value="0.6" units="cm"/>
+      <inkml:brushProperty name="color" value="#D9AEFF"/>
+      <inkml:brushProperty name="tip" value="rectangle"/>
+      <inkml:brushProperty name="rasterOp" value="maskPen"/>
+      <inkml:brushProperty name="ignorePressure" value="1"/>
+    </inkml:brush>
+  </inkml:definitions>
+  <inkml:trace contextRef="#ctx0" brushRef="#br0">0 0,'0'0</inkml:trace>
+</inkml:ink>
+</file>
+
+<file path=ppt/ink/ink2.xml><?xml version="1.0" encoding="utf-8"?>
+<inkml:ink xmlns:inkml="http://www.w3.org/2003/InkML">
+  <inkml:definitions>
+    <inkml:context xml:id="ctx0">
+      <inkml:inkSource xml:id="inkSrc0">
+        <inkml:traceFormat>
+          <inkml:channel name="X" type="integer" min="-2.14748E9" max="2.14748E9" units="cm"/>
+          <inkml:channel name="Y" type="integer" min="-2.14748E9" max="2.14748E9" units="cm"/>
+        </inkml:traceFormat>
+        <inkml:channelProperties>
+          <inkml:channelProperty channel="X" name="resolution" value="1000" units="1/cm"/>
+          <inkml:channelProperty channel="Y" name="resolution" value="1000" units="1/cm"/>
+        </inkml:channelProperties>
+      </inkml:inkSource>
+      <inkml:timestamp xml:id="ts0" timeString="2026-03-18T09:23:01.795"/>
+    </inkml:context>
+    <inkml:brush xml:id="br0">
+      <inkml:brushProperty name="width" value="0.3" units="cm"/>
+      <inkml:brushProperty name="height" value="0.6" units="cm"/>
+      <inkml:brushProperty name="color" value="#D9AEFF"/>
+      <inkml:brushProperty name="tip" value="rectangle"/>
+      <inkml:brushProperty name="rasterOp" value="maskPen"/>
+      <inkml:brushProperty name="ignorePressure" value="1"/>
+    </inkml:brush>
+  </inkml:definitions>
+  <inkml:trace contextRef="#ctx0" brushRef="#br0">0 145,'793'-17,"-680"11,183-17,-124 13,-7 1,-144 6,0-1,-1-1,1 0,-1-2,34-15,-40 16,1 0,0 1,0 1,0 0,1 1,27-2,97 4,-77 3,1123 0,-1161-2</inkml:trace>
+</inkml:ink>
+</file>
+
+<file path=ppt/ink/ink3.xml><?xml version="1.0" encoding="utf-8"?>
+<inkml:ink xmlns:inkml="http://www.w3.org/2003/InkML">
+  <inkml:definitions>
+    <inkml:context xml:id="ctx0">
+      <inkml:inkSource xml:id="inkSrc0">
+        <inkml:traceFormat>
+          <inkml:channel name="X" type="integer" min="-2.14748E9" max="2.14748E9" units="cm"/>
+          <inkml:channel name="Y" type="integer" min="-2.14748E9" max="2.14748E9" units="cm"/>
+        </inkml:traceFormat>
+        <inkml:channelProperties>
+          <inkml:channelProperty channel="X" name="resolution" value="1000" units="1/cm"/>
+          <inkml:channelProperty channel="Y" name="resolution" value="1000" units="1/cm"/>
+        </inkml:channelProperties>
+      </inkml:inkSource>
+      <inkml:timestamp xml:id="ts0" timeString="2026-03-18T09:23:09.843"/>
+    </inkml:context>
+    <inkml:brush xml:id="br0">
+      <inkml:brushProperty name="width" value="0.3" units="cm"/>
+      <inkml:brushProperty name="height" value="0.6" units="cm"/>
+      <inkml:brushProperty name="color" value="#00FDFF"/>
+      <inkml:brushProperty name="tip" value="rectangle"/>
+      <inkml:brushProperty name="rasterOp" value="maskPen"/>
+      <inkml:brushProperty name="ignorePressure" value="1"/>
+    </inkml:brush>
+  </inkml:definitions>
+  <inkml:trace contextRef="#ctx0" brushRef="#br0">0 0,'0'0</inkml:trace>
+</inkml:ink>
+</file>
+
+<file path=ppt/ink/ink4.xml><?xml version="1.0" encoding="utf-8"?>
+<inkml:ink xmlns:inkml="http://www.w3.org/2003/InkML">
+  <inkml:definitions>
+    <inkml:context xml:id="ctx0">
+      <inkml:inkSource xml:id="inkSrc0">
+        <inkml:traceFormat>
+          <inkml:channel name="X" type="integer" min="-2.14748E9" max="2.14748E9" units="cm"/>
+          <inkml:channel name="Y" type="integer" min="-2.14748E9" max="2.14748E9" units="cm"/>
+        </inkml:traceFormat>
+        <inkml:channelProperties>
+          <inkml:channelProperty channel="X" name="resolution" value="1000" units="1/cm"/>
+          <inkml:channelProperty channel="Y" name="resolution" value="1000" units="1/cm"/>
+        </inkml:channelProperties>
+      </inkml:inkSource>
+      <inkml:timestamp xml:id="ts0" timeString="2026-03-18T09:23:12.687"/>
+    </inkml:context>
+    <inkml:brush xml:id="br0">
+      <inkml:brushProperty name="width" value="0.3" units="cm"/>
+      <inkml:brushProperty name="height" value="0.6" units="cm"/>
+      <inkml:brushProperty name="color" value="#00FDFF"/>
+      <inkml:brushProperty name="tip" value="rectangle"/>
+      <inkml:brushProperty name="rasterOp" value="maskPen"/>
+      <inkml:brushProperty name="ignorePressure" value="1"/>
+    </inkml:brush>
+  </inkml:definitions>
+  <inkml:trace contextRef="#ctx0" brushRef="#br0">0 200,'38'0,"-9"1,1-1,-1-1,0-2,1-1,38-10,-2-7,366-96,-418 114,52-10,1 2,104-3,847 17,-754 11,-8 1,610-16,-850 1,1 2,-1 0,0 1,-1 1,1 0,-1 1,1 1,26 14,-42-20,1 0,0 0,-1 0,1 0,-1 1,1-1,-1 0,1 1,-1-1,1 0,-1 1,1-1,-1 0,1 1,-1-1,1 1,-1-1,0 1,1-1,-1 1,0 0,0-1,1 1,-1-1,0 1,0-1,0 1,0 0,0-1,0 1,0-1,0 1,0 0,0 0,-1 1,0-1,0 0,0 0,-1 0,1 0,0-1,0 1,-1 0,1 0,-1-1,1 1,0-1,-3 1,-48 9,-257-7,163-5,-1108 2,1232 0,0 1,0 0,0 2,0 1,0 1,1 0,0 2,0 0,1 2,-21 10,24-8</inkml:trace>
+</inkml:ink>
+</file>
+
+<file path=ppt/ink/ink5.xml><?xml version="1.0" encoding="utf-8"?>
+<inkml:ink xmlns:inkml="http://www.w3.org/2003/InkML">
+  <inkml:definitions>
+    <inkml:context xml:id="ctx0">
+      <inkml:inkSource xml:id="inkSrc0">
+        <inkml:traceFormat>
+          <inkml:channel name="X" type="integer" min="-2.14748E9" max="2.14748E9" units="cm"/>
+          <inkml:channel name="Y" type="integer" min="-2.14748E9" max="2.14748E9" units="cm"/>
+        </inkml:traceFormat>
+        <inkml:channelProperties>
+          <inkml:channelProperty channel="X" name="resolution" value="1000" units="1/cm"/>
+          <inkml:channelProperty channel="Y" name="resolution" value="1000" units="1/cm"/>
+        </inkml:channelProperties>
+      </inkml:inkSource>
+      <inkml:timestamp xml:id="ts0" timeString="2026-03-18T09:23:13.695"/>
+    </inkml:context>
+    <inkml:brush xml:id="br0">
+      <inkml:brushProperty name="width" value="0.3" units="cm"/>
+      <inkml:brushProperty name="height" value="0.6" units="cm"/>
+      <inkml:brushProperty name="color" value="#00FDFF"/>
+      <inkml:brushProperty name="tip" value="rectangle"/>
+      <inkml:brushProperty name="rasterOp" value="maskPen"/>
+      <inkml:brushProperty name="ignorePressure" value="1"/>
+    </inkml:brush>
+  </inkml:definitions>
+  <inkml:trace contextRef="#ctx0" brushRef="#br0">1 29,'19'0,"50"0,32 0,46 0,48 0,51 0,43 0,19 0,-23 0,-45-5,-55-1,-43 0,-38 1,-20 2,-21 1,-16 0,-16 2</inkml:trace>
+</inkml:ink>
+</file>
+
+<file path=ppt/ink/ink6.xml><?xml version="1.0" encoding="utf-8"?>
+<inkml:ink xmlns:inkml="http://www.w3.org/2003/InkML">
+  <inkml:definitions>
+    <inkml:context xml:id="ctx0">
+      <inkml:inkSource xml:id="inkSrc0">
+        <inkml:traceFormat>
+          <inkml:channel name="X" type="integer" min="-2.14748E9" max="2.14748E9" units="cm"/>
+          <inkml:channel name="Y" type="integer" min="-2.14748E9" max="2.14748E9" units="cm"/>
+        </inkml:traceFormat>
+        <inkml:channelProperties>
+          <inkml:channelProperty channel="X" name="resolution" value="1000" units="1/cm"/>
+          <inkml:channelProperty channel="Y" name="resolution" value="1000" units="1/cm"/>
+        </inkml:channelProperties>
+      </inkml:inkSource>
+      <inkml:timestamp xml:id="ts0" timeString="2026-03-18T09:23:15.755"/>
+    </inkml:context>
+    <inkml:brush xml:id="br0">
+      <inkml:brushProperty name="width" value="0.3" units="cm"/>
+      <inkml:brushProperty name="height" value="0.6" units="cm"/>
+      <inkml:brushProperty name="color" value="#00FDFF"/>
+      <inkml:brushProperty name="tip" value="rectangle"/>
+      <inkml:brushProperty name="rasterOp" value="maskPen"/>
+      <inkml:brushProperty name="ignorePressure" value="1"/>
+    </inkml:brush>
+  </inkml:definitions>
+  <inkml:trace contextRef="#ctx0" brushRef="#br0">0 315,'500'0,"-449"-3,-1-3,1-1,64-19,39-5,15 9,283 2,-394 18,1-3,58-13,17-2,89-9,139-14,129-12,-369 40,-66 8,0 3,1 3,-1 2,1 2,-1 3,0 3,73 20,127 36,-243-63,0 2,0-1,0 2,0 0,-1 0,0 1,21 14,-16-5</inkml:trace>
+</inkml:ink>
+</file>
+
+<file path=ppt/ink/ink7.xml><?xml version="1.0" encoding="utf-8"?>
+<inkml:ink xmlns:inkml="http://www.w3.org/2003/InkML">
+  <inkml:definitions>
+    <inkml:context xml:id="ctx0">
+      <inkml:inkSource xml:id="inkSrc0">
+        <inkml:traceFormat>
+          <inkml:channel name="X" type="integer" min="-2.14748E9" max="2.14748E9" units="cm"/>
+          <inkml:channel name="Y" type="integer" min="-2.14748E9" max="2.14748E9" units="cm"/>
+        </inkml:traceFormat>
+        <inkml:channelProperties>
+          <inkml:channelProperty channel="X" name="resolution" value="1000" units="1/cm"/>
+          <inkml:channelProperty channel="Y" name="resolution" value="1000" units="1/cm"/>
+        </inkml:channelProperties>
+      </inkml:inkSource>
+      <inkml:timestamp xml:id="ts0" timeString="2026-03-18T09:23:16.520"/>
+    </inkml:context>
+    <inkml:brush xml:id="br0">
+      <inkml:brushProperty name="width" value="0.3" units="cm"/>
+      <inkml:brushProperty name="height" value="0.6" units="cm"/>
+      <inkml:brushProperty name="color" value="#00FDFF"/>
+      <inkml:brushProperty name="tip" value="rectangle"/>
+      <inkml:brushProperty name="rasterOp" value="maskPen"/>
+      <inkml:brushProperty name="ignorePressure" value="1"/>
+    </inkml:brush>
+  </inkml:definitions>
+  <inkml:trace contextRef="#ctx0" brushRef="#br0">0 251,'115'0,"332"-4,-1-35,-353 25,554-65,233 45,-805 30,-1-3,78-19,-116 20,138-17,-95 14,-38 4</inkml:trace>
+</inkml:ink>
+</file>
+
+<file path=ppt/ink/ink8.xml><?xml version="1.0" encoding="utf-8"?>
+<inkml:ink xmlns:inkml="http://www.w3.org/2003/InkML">
+  <inkml:definitions>
+    <inkml:context xml:id="ctx0">
+      <inkml:inkSource xml:id="inkSrc0">
+        <inkml:traceFormat>
+          <inkml:channel name="X" type="integer" min="-2.14748E9" max="2.14748E9" units="cm"/>
+          <inkml:channel name="Y" type="integer" min="-2.14748E9" max="2.14748E9" units="cm"/>
+        </inkml:traceFormat>
+        <inkml:channelProperties>
+          <inkml:channelProperty channel="X" name="resolution" value="1000" units="1/cm"/>
+          <inkml:channelProperty channel="Y" name="resolution" value="1000" units="1/cm"/>
+        </inkml:channelProperties>
+      </inkml:inkSource>
+      <inkml:timestamp xml:id="ts0" timeString="2026-03-18T09:23:17.715"/>
+    </inkml:context>
+    <inkml:brush xml:id="br0">
+      <inkml:brushProperty name="width" value="0.3" units="cm"/>
+      <inkml:brushProperty name="height" value="0.6" units="cm"/>
+      <inkml:brushProperty name="color" value="#00FDFF"/>
+      <inkml:brushProperty name="tip" value="rectangle"/>
+      <inkml:brushProperty name="rasterOp" value="maskPen"/>
+      <inkml:brushProperty name="ignorePressure" value="1"/>
+    </inkml:brush>
+  </inkml:definitions>
+  <inkml:trace contextRef="#ctx0" brushRef="#br0">0 111,'315'1,"339"-3,-621 2,146-8,-149 5,-1-2,1-1,55-18,-53 13,1 2,1 1,50-5,108-1,-148 12,157-5,284 26,-434-13,433 26,-318-34,287 3,-391 3,0 3,0 3,-1 2,83 28,-68-18,1-4,81 8,-109-21</inkml:trace>
+</inkml:ink>
+</file>
+
+<file path=ppt/ink/ink9.xml><?xml version="1.0" encoding="utf-8"?>
+<inkml:ink xmlns:inkml="http://www.w3.org/2003/InkML">
+  <inkml:definitions>
+    <inkml:context xml:id="ctx0">
+      <inkml:inkSource xml:id="inkSrc0">
+        <inkml:traceFormat>
+          <inkml:channel name="X" type="integer" min="-2.14748E9" max="2.14748E9" units="cm"/>
+          <inkml:channel name="Y" type="integer" min="-2.14748E9" max="2.14748E9" units="cm"/>
+        </inkml:traceFormat>
+        <inkml:channelProperties>
+          <inkml:channelProperty channel="X" name="resolution" value="1000" units="1/cm"/>
+          <inkml:channelProperty channel="Y" name="resolution" value="1000" units="1/cm"/>
+        </inkml:channelProperties>
+      </inkml:inkSource>
+      <inkml:timestamp xml:id="ts0" timeString="2026-03-18T09:23:18.929"/>
+    </inkml:context>
+    <inkml:brush xml:id="br0">
+      <inkml:brushProperty name="width" value="0.3" units="cm"/>
+      <inkml:brushProperty name="height" value="0.6" units="cm"/>
+      <inkml:brushProperty name="color" value="#00FDFF"/>
+      <inkml:brushProperty name="tip" value="rectangle"/>
+      <inkml:brushProperty name="rasterOp" value="maskPen"/>
+      <inkml:brushProperty name="ignorePressure" value="1"/>
+    </inkml:brush>
+  </inkml:definitions>
+  <inkml:trace contextRef="#ctx0" brushRef="#br0">1 279,'29'-12,"2"1,-1 2,1 1,1 1,33-2,-42 5,493-44,9 40,162-37,-383 16,-214 19,92-24,-134 26,1 2,57 1,-22 2,-9-8,-54 7,0 0,27 0,-11 5,0 2,0 1,42 11,109 36,-20-4,-119-33,70 30,-77-27,0-1,65 14,-31-20,-47-8</inkml:trace>
+</inkml:ink>
+</file>
+
 <file path=ppt/slideLayouts/slideLayout1.xml><?xml version="1.0" encoding="utf-8"?>
 <p:sldLayout xmlns:a="http://schemas.openxmlformats.org/drawingml/2006/main" xmlns:r="http://schemas.openxmlformats.org/officeDocument/2006/relationships" xmlns:p="http://schemas.openxmlformats.org/presentationml/2006/main" type="title" preserve="1">
   <p:cSld name="Titelfolie">
@@ -6539,7 +6805,7 @@
           <a:p>
             <a:fld id="{AB4A5B31-C8C7-4C22-B0E9-873766B6517D}" type="datetimeFigureOut">
               <a:rPr lang="de-DE" smtClean="0"/>
-              <a:t>17.03.2026</a:t>
+              <a:t>18.03.2026</a:t>
             </a:fld>
             <a:endParaRPr lang="de-DE"/>
           </a:p>
@@ -6851,7 +7117,7 @@
           <a:p>
             <a:fld id="{AB4A5B31-C8C7-4C22-B0E9-873766B6517D}" type="datetimeFigureOut">
               <a:rPr lang="de-DE" smtClean="0"/>
-              <a:t>17.03.2026</a:t>
+              <a:t>18.03.2026</a:t>
             </a:fld>
             <a:endParaRPr lang="de-DE"/>
           </a:p>
@@ -7073,7 +7339,7 @@
           <a:p>
             <a:fld id="{AB4A5B31-C8C7-4C22-B0E9-873766B6517D}" type="datetimeFigureOut">
               <a:rPr lang="de-DE" smtClean="0"/>
-              <a:t>17.03.2026</a:t>
+              <a:t>18.03.2026</a:t>
             </a:fld>
             <a:endParaRPr lang="de-DE"/>
           </a:p>
@@ -7364,7 +7630,7 @@
           <a:p>
             <a:fld id="{AB4A5B31-C8C7-4C22-B0E9-873766B6517D}" type="datetimeFigureOut">
               <a:rPr lang="de-DE" smtClean="0"/>
-              <a:t>17.03.2026</a:t>
+              <a:t>18.03.2026</a:t>
             </a:fld>
             <a:endParaRPr lang="de-DE"/>
           </a:p>
@@ -7818,7 +8084,7 @@
           <a:p>
             <a:fld id="{AB4A5B31-C8C7-4C22-B0E9-873766B6517D}" type="datetimeFigureOut">
               <a:rPr lang="de-DE" smtClean="0"/>
-              <a:t>17.03.2026</a:t>
+              <a:t>18.03.2026</a:t>
             </a:fld>
             <a:endParaRPr lang="de-DE"/>
           </a:p>
@@ -8394,7 +8660,7 @@
           <a:p>
             <a:fld id="{AB4A5B31-C8C7-4C22-B0E9-873766B6517D}" type="datetimeFigureOut">
               <a:rPr lang="de-DE" smtClean="0"/>
-              <a:t>17.03.2026</a:t>
+              <a:t>18.03.2026</a:t>
             </a:fld>
             <a:endParaRPr lang="de-DE"/>
           </a:p>
@@ -9246,7 +9512,7 @@
           <a:p>
             <a:fld id="{AB4A5B31-C8C7-4C22-B0E9-873766B6517D}" type="datetimeFigureOut">
               <a:rPr lang="de-DE" smtClean="0"/>
-              <a:t>17.03.2026</a:t>
+              <a:t>18.03.2026</a:t>
             </a:fld>
             <a:endParaRPr lang="de-DE"/>
           </a:p>
@@ -9451,7 +9717,7 @@
           <a:p>
             <a:fld id="{AB4A5B31-C8C7-4C22-B0E9-873766B6517D}" type="datetimeFigureOut">
               <a:rPr lang="de-DE" smtClean="0"/>
-              <a:t>17.03.2026</a:t>
+              <a:t>18.03.2026</a:t>
             </a:fld>
             <a:endParaRPr lang="de-DE"/>
           </a:p>
@@ -9665,7 +9931,7 @@
           <a:p>
             <a:fld id="{AB4A5B31-C8C7-4C22-B0E9-873766B6517D}" type="datetimeFigureOut">
               <a:rPr lang="de-DE" smtClean="0"/>
-              <a:t>17.03.2026</a:t>
+              <a:t>18.03.2026</a:t>
             </a:fld>
             <a:endParaRPr lang="de-DE"/>
           </a:p>
@@ -9835,7 +10101,7 @@
           <a:p>
             <a:fld id="{AB4A5B31-C8C7-4C22-B0E9-873766B6517D}" type="datetimeFigureOut">
               <a:rPr lang="de-DE" smtClean="0"/>
-              <a:t>17.03.2026</a:t>
+              <a:t>18.03.2026</a:t>
             </a:fld>
             <a:endParaRPr lang="de-DE"/>
           </a:p>
@@ -10040,7 +10306,7 @@
           <a:p>
             <a:fld id="{AB4A5B31-C8C7-4C22-B0E9-873766B6517D}" type="datetimeFigureOut">
               <a:rPr lang="de-DE" smtClean="0"/>
-              <a:t>17.03.2026</a:t>
+              <a:t>18.03.2026</a:t>
             </a:fld>
             <a:endParaRPr lang="de-DE"/>
           </a:p>
@@ -10320,7 +10586,7 @@
           <a:p>
             <a:fld id="{AB4A5B31-C8C7-4C22-B0E9-873766B6517D}" type="datetimeFigureOut">
               <a:rPr lang="de-DE" smtClean="0"/>
-              <a:t>17.03.2026</a:t>
+              <a:t>18.03.2026</a:t>
             </a:fld>
             <a:endParaRPr lang="de-DE"/>
           </a:p>
@@ -10587,7 +10853,7 @@
           <a:p>
             <a:fld id="{AB4A5B31-C8C7-4C22-B0E9-873766B6517D}" type="datetimeFigureOut">
               <a:rPr lang="de-DE" smtClean="0"/>
-              <a:t>17.03.2026</a:t>
+              <a:t>18.03.2026</a:t>
             </a:fld>
             <a:endParaRPr lang="de-DE"/>
           </a:p>
@@ -11002,7 +11268,7 @@
           <a:p>
             <a:fld id="{AB4A5B31-C8C7-4C22-B0E9-873766B6517D}" type="datetimeFigureOut">
               <a:rPr lang="de-DE" smtClean="0"/>
-              <a:t>17.03.2026</a:t>
+              <a:t>18.03.2026</a:t>
             </a:fld>
             <a:endParaRPr lang="de-DE"/>
           </a:p>
@@ -11150,7 +11416,7 @@
           <a:p>
             <a:fld id="{AB4A5B31-C8C7-4C22-B0E9-873766B6517D}" type="datetimeFigureOut">
               <a:rPr lang="de-DE" smtClean="0"/>
-              <a:t>17.03.2026</a:t>
+              <a:t>18.03.2026</a:t>
             </a:fld>
             <a:endParaRPr lang="de-DE"/>
           </a:p>
@@ -11275,7 +11541,7 @@
           <a:p>
             <a:fld id="{AB4A5B31-C8C7-4C22-B0E9-873766B6517D}" type="datetimeFigureOut">
               <a:rPr lang="de-DE" smtClean="0"/>
-              <a:t>17.03.2026</a:t>
+              <a:t>18.03.2026</a:t>
             </a:fld>
             <a:endParaRPr lang="de-DE"/>
           </a:p>
@@ -11554,7 +11820,7 @@
           <a:p>
             <a:fld id="{AB4A5B31-C8C7-4C22-B0E9-873766B6517D}" type="datetimeFigureOut">
               <a:rPr lang="de-DE" smtClean="0"/>
-              <a:t>17.03.2026</a:t>
+              <a:t>18.03.2026</a:t>
             </a:fld>
             <a:endParaRPr lang="de-DE"/>
           </a:p>
@@ -11866,7 +12132,7 @@
           <a:p>
             <a:fld id="{AB4A5B31-C8C7-4C22-B0E9-873766B6517D}" type="datetimeFigureOut">
               <a:rPr lang="de-DE" smtClean="0"/>
-              <a:t>17.03.2026</a:t>
+              <a:t>18.03.2026</a:t>
             </a:fld>
             <a:endParaRPr lang="de-DE"/>
           </a:p>
@@ -12119,7 +12385,7 @@
           <a:p>
             <a:fld id="{AB4A5B31-C8C7-4C22-B0E9-873766B6517D}" type="datetimeFigureOut">
               <a:rPr lang="de-DE" smtClean="0"/>
-              <a:t>17.03.2026</a:t>
+              <a:t>18.03.2026</a:t>
             </a:fld>
             <a:endParaRPr lang="de-DE"/>
           </a:p>
@@ -13694,39 +13960,6 @@
       </p:pic>
       <p:pic>
         <p:nvPicPr>
-          <p:cNvPr id="4" name="Inhaltsplatzhalter 6">
-            <a:extLst>
-              <a:ext uri="{FF2B5EF4-FFF2-40B4-BE49-F238E27FC236}">
-                <a16:creationId xmlns:a16="http://schemas.microsoft.com/office/drawing/2014/main" id="{25A55F56-C8AA-20F2-4136-1D1AA8C4B4CD}"/>
-              </a:ext>
-            </a:extLst>
-          </p:cNvPr>
-          <p:cNvPicPr>
-            <a:picLocks noGrp="1" noChangeAspect="1"/>
-          </p:cNvPicPr>
-          <p:nvPr>
-            <p:ph idx="1"/>
-          </p:nvPr>
-        </p:nvPicPr>
-        <p:blipFill>
-          <a:blip r:embed="rId5"/>
-          <a:srcRect b="7602"/>
-          <a:stretch>
-            <a:fillRect/>
-          </a:stretch>
-        </p:blipFill>
-        <p:spPr>
-          <a:xfrm>
-            <a:off x="2223436" y="-2"/>
-            <a:ext cx="9968564" cy="6840676"/>
-          </a:xfrm>
-          <a:prstGeom prst="rect">
-            <a:avLst/>
-          </a:prstGeom>
-        </p:spPr>
-      </p:pic>
-      <p:pic>
-        <p:nvPicPr>
           <p:cNvPr id="19" name="Picture 18">
             <a:extLst>
               <a:ext uri="{FF2B5EF4-FFF2-40B4-BE49-F238E27FC236}">
@@ -13763,6 +13996,45 @@
           <a:xfrm flipH="1">
             <a:off x="0" y="3142319"/>
             <a:ext cx="4605339" cy="3715682"/>
+          </a:xfrm>
+          <a:prstGeom prst="rect">
+            <a:avLst/>
+          </a:prstGeom>
+        </p:spPr>
+      </p:pic>
+      <p:pic>
+        <p:nvPicPr>
+          <p:cNvPr id="10" name="Inhaltsplatzhalter 9">
+            <a:extLst>
+              <a:ext uri="{FF2B5EF4-FFF2-40B4-BE49-F238E27FC236}">
+                <a16:creationId xmlns:a16="http://schemas.microsoft.com/office/drawing/2014/main" id="{54D028B5-EC39-868C-6057-0AA71BD4E96C}"/>
+              </a:ext>
+            </a:extLst>
+          </p:cNvPr>
+          <p:cNvPicPr>
+            <a:picLocks noGrp="1" noChangeAspect="1"/>
+          </p:cNvPicPr>
+          <p:nvPr>
+            <p:ph idx="1"/>
+          </p:nvPr>
+        </p:nvPicPr>
+        <p:blipFill>
+          <a:blip r:embed="rId5">
+            <a:extLst>
+              <a:ext uri="{28A0092B-C50C-407E-A947-70E740481C1C}">
+                <a14:useLocalDpi xmlns:a14="http://schemas.microsoft.com/office/drawing/2010/main" val="0"/>
+              </a:ext>
+            </a:extLst>
+          </a:blip>
+          <a:srcRect b="7230"/>
+          <a:stretch>
+            <a:fillRect/>
+          </a:stretch>
+        </p:blipFill>
+        <p:spPr>
+          <a:xfrm>
+            <a:off x="2398439" y="-21952"/>
+            <a:ext cx="9793561" cy="6886207"/>
           </a:xfrm>
           <a:prstGeom prst="rect">
             <a:avLst/>
@@ -14166,277 +14438,525 @@
           </a:p>
         </p:txBody>
       </p:sp>
-      <p:sp>
-        <p:nvSpPr>
-          <p:cNvPr id="4" name="Rectangle 1">
+      <p:pic>
+        <p:nvPicPr>
+          <p:cNvPr id="5" name="Grafik 4">
             <a:extLst>
               <a:ext uri="{FF2B5EF4-FFF2-40B4-BE49-F238E27FC236}">
-                <a16:creationId xmlns:a16="http://schemas.microsoft.com/office/drawing/2014/main" id="{562E0BCB-2855-A994-EF5E-3F04F0DF6A8B}"/>
+                <a16:creationId xmlns:a16="http://schemas.microsoft.com/office/drawing/2014/main" id="{F06C4B73-2F48-EB07-AB1A-ED6CDD838A3D}"/>
               </a:ext>
             </a:extLst>
           </p:cNvPr>
-          <p:cNvSpPr>
-            <a:spLocks noGrp="1" noChangeArrowheads="1"/>
-          </p:cNvSpPr>
-          <p:nvPr>
-            <p:ph idx="1"/>
-          </p:nvPr>
-        </p:nvSpPr>
-        <p:spPr bwMode="auto">
+          <p:cNvPicPr>
+            <a:picLocks noChangeAspect="1"/>
+          </p:cNvPicPr>
+          <p:nvPr/>
+        </p:nvPicPr>
+        <p:blipFill>
+          <a:blip r:embed="rId2"/>
+          <a:stretch>
+            <a:fillRect/>
+          </a:stretch>
+        </p:blipFill>
+        <p:spPr>
+          <a:xfrm>
+            <a:off x="486827" y="1680474"/>
+            <a:ext cx="11218346" cy="2657846"/>
+          </a:xfrm>
           <a:prstGeom prst="rect">
             <a:avLst/>
           </a:prstGeom>
-          <a:noFill/>
-          <a:ln>
-            <a:noFill/>
-          </a:ln>
-          <a:effectLst/>
-          <a:extLst>
-            <a:ext uri="{909E8E84-426E-40DD-AFC4-6F175D3DCCD1}">
-              <a14:hiddenFill xmlns:a14="http://schemas.microsoft.com/office/drawing/2010/main">
-                <a:solidFill>
-                  <a:schemeClr val="accent1"/>
-                </a:solidFill>
-              </a14:hiddenFill>
-            </a:ext>
-            <a:ext uri="{91240B29-F687-4F45-9708-019B960494DF}">
-              <a14:hiddenLine xmlns:a14="http://schemas.microsoft.com/office/drawing/2010/main" w="9525">
-                <a:solidFill>
-                  <a:schemeClr val="tx1"/>
-                </a:solidFill>
-                <a:miter lim="800000"/>
-                <a:headEnd/>
-                <a:tailEnd/>
-              </a14:hiddenLine>
-            </a:ext>
-            <a:ext uri="{AF507438-7753-43E0-B8FC-AC1667EBCBE1}">
-              <a14:hiddenEffects xmlns:a14="http://schemas.microsoft.com/office/drawing/2010/main">
-                <a:effectLst>
-                  <a:outerShdw dist="35921" dir="2700000" algn="ctr" rotWithShape="0">
-                    <a:schemeClr val="bg2"/>
-                  </a:outerShdw>
-                </a:effectLst>
-              </a14:hiddenEffects>
-            </a:ext>
-          </a:extLst>
         </p:spPr>
-        <p:txBody>
-          <a:bodyPr vert="horz" wrap="none" lIns="91440" tIns="45720" rIns="91440" bIns="45720" numCol="1" anchor="ctr" anchorCtr="0" compatLnSpc="1">
-            <a:prstTxWarp prst="textNoShape">
-              <a:avLst/>
-            </a:prstTxWarp>
-            <a:spAutoFit/>
-          </a:bodyPr>
-          <a:lstStyle/>
-          <a:p>
-            <a:pPr marL="0" marR="0" lvl="0" indent="0" algn="l" defTabSz="914400" rtl="0" eaLnBrk="0" fontAlgn="base" latinLnBrk="0" hangingPunct="0">
-              <a:lnSpc>
-                <a:spcPct val="100000"/>
-              </a:lnSpc>
-              <a:spcBef>
-                <a:spcPct val="0"/>
-              </a:spcBef>
-              <a:spcAft>
-                <a:spcPct val="0"/>
-              </a:spcAft>
-              <a:buClrTx/>
-              <a:buSzTx/>
-              <a:buFontTx/>
-              <a:buChar char="•"/>
-              <a:tabLst/>
-            </a:pPr>
-            <a:r>
-              <a:rPr kumimoji="0" lang="de-DE" altLang="de-DE" sz="1800" b="0" i="0" u="none" strike="noStrike" cap="none" normalizeH="0" baseline="0" dirty="0">
-                <a:ln>
-                  <a:noFill/>
-                </a:ln>
-                <a:solidFill>
-                  <a:schemeClr val="tx1"/>
-                </a:solidFill>
-                <a:effectLst/>
-                <a:latin typeface="Arial" panose="020B0604020202020204" pitchFamily="34" charset="0"/>
-              </a:rPr>
-              <a:t>Ein kurzer Screenshot aus eurem DDL-Skript (am besten die Tabellen </a:t>
-            </a:r>
-            <a:r>
-              <a:rPr kumimoji="0" lang="de-DE" altLang="de-DE" sz="1000" b="0" i="0" u="none" strike="noStrike" cap="none" normalizeH="0" baseline="0" dirty="0">
-                <a:ln>
-                  <a:noFill/>
-                </a:ln>
-                <a:solidFill>
-                  <a:schemeClr val="tx1"/>
-                </a:solidFill>
-                <a:effectLst/>
-                <a:latin typeface="Arial Unicode MS"/>
-              </a:rPr>
-              <a:t>Kunde</a:t>
-            </a:r>
-            <a:r>
-              <a:rPr kumimoji="0" lang="de-DE" altLang="de-DE" sz="800" b="0" i="0" u="none" strike="noStrike" cap="none" normalizeH="0" baseline="0" dirty="0">
-                <a:ln>
-                  <a:noFill/>
-                </a:ln>
-                <a:solidFill>
-                  <a:schemeClr val="tx1"/>
-                </a:solidFill>
-                <a:effectLst/>
-              </a:rPr>
-              <a:t> und </a:t>
-            </a:r>
-            <a:r>
-              <a:rPr kumimoji="0" lang="de-DE" altLang="de-DE" sz="1000" b="0" i="0" u="none" strike="noStrike" cap="none" normalizeH="0" baseline="0" dirty="0">
-                <a:ln>
-                  <a:noFill/>
-                </a:ln>
-                <a:solidFill>
-                  <a:schemeClr val="tx1"/>
-                </a:solidFill>
-                <a:effectLst/>
-                <a:latin typeface="Arial Unicode MS"/>
-              </a:rPr>
-              <a:t>Verkaufsposition</a:t>
-            </a:r>
-            <a:r>
-              <a:rPr kumimoji="0" lang="de-DE" altLang="de-DE" sz="800" b="0" i="0" u="none" strike="noStrike" cap="none" normalizeH="0" baseline="0" dirty="0">
-                <a:ln>
-                  <a:noFill/>
-                </a:ln>
-                <a:solidFill>
-                  <a:schemeClr val="tx1"/>
-                </a:solidFill>
-                <a:effectLst/>
-              </a:rPr>
-              <a:t>).</a:t>
-            </a:r>
-            <a:endParaRPr kumimoji="0" lang="de-DE" altLang="de-DE" sz="1800" b="0" i="0" u="none" strike="noStrike" cap="none" normalizeH="0" baseline="0" dirty="0">
-              <a:ln>
-                <a:noFill/>
-              </a:ln>
-              <a:solidFill>
-                <a:schemeClr val="tx1"/>
-              </a:solidFill>
-              <a:effectLst/>
-              <a:latin typeface="Arial" panose="020B0604020202020204" pitchFamily="34" charset="0"/>
-            </a:endParaRPr>
-          </a:p>
-          <a:p>
-            <a:pPr marL="0" marR="0" lvl="0" indent="0" algn="l" defTabSz="914400" rtl="0" eaLnBrk="0" fontAlgn="base" latinLnBrk="0" hangingPunct="0">
-              <a:lnSpc>
-                <a:spcPct val="100000"/>
-              </a:lnSpc>
-              <a:spcBef>
-                <a:spcPct val="0"/>
-              </a:spcBef>
-              <a:spcAft>
-                <a:spcPct val="0"/>
-              </a:spcAft>
-              <a:buClrTx/>
-              <a:buSzTx/>
-              <a:buFontTx/>
-              <a:buChar char="•"/>
-              <a:tabLst/>
-            </a:pPr>
-            <a:r>
-              <a:rPr kumimoji="0" lang="de-DE" altLang="de-DE" sz="1800" b="0" i="0" u="none" strike="noStrike" cap="none" normalizeH="0" baseline="0" dirty="0">
-                <a:ln>
-                  <a:noFill/>
-                </a:ln>
-                <a:solidFill>
-                  <a:schemeClr val="tx1"/>
-                </a:solidFill>
-                <a:effectLst/>
-                <a:latin typeface="Arial" panose="020B0604020202020204" pitchFamily="34" charset="0"/>
-              </a:rPr>
-              <a:t>Markierungen bei Datentypen (</a:t>
-            </a:r>
-            <a:r>
-              <a:rPr kumimoji="0" lang="de-DE" altLang="de-DE" sz="1000" b="0" i="0" u="none" strike="noStrike" cap="none" normalizeH="0" baseline="0" dirty="0">
-                <a:ln>
-                  <a:noFill/>
-                </a:ln>
-                <a:solidFill>
-                  <a:schemeClr val="tx1"/>
-                </a:solidFill>
-                <a:effectLst/>
-                <a:latin typeface="Arial Unicode MS"/>
-              </a:rPr>
-              <a:t>VARCHAR2</a:t>
-            </a:r>
-            <a:r>
-              <a:rPr kumimoji="0" lang="de-DE" altLang="de-DE" sz="800" b="0" i="0" u="none" strike="noStrike" cap="none" normalizeH="0" baseline="0" dirty="0">
-                <a:ln>
-                  <a:noFill/>
-                </a:ln>
-                <a:solidFill>
-                  <a:schemeClr val="tx1"/>
-                </a:solidFill>
-                <a:effectLst/>
-              </a:rPr>
-              <a:t>, </a:t>
-            </a:r>
-            <a:r>
-              <a:rPr kumimoji="0" lang="de-DE" altLang="de-DE" sz="1000" b="0" i="0" u="none" strike="noStrike" cap="none" normalizeH="0" baseline="0" dirty="0">
-                <a:ln>
-                  <a:noFill/>
-                </a:ln>
-                <a:solidFill>
-                  <a:schemeClr val="tx1"/>
-                </a:solidFill>
-                <a:effectLst/>
-                <a:latin typeface="Arial Unicode MS"/>
-              </a:rPr>
-              <a:t>NUMBER(10,2)</a:t>
-            </a:r>
-            <a:r>
-              <a:rPr kumimoji="0" lang="de-DE" altLang="de-DE" sz="800" b="0" i="0" u="none" strike="noStrike" cap="none" normalizeH="0" baseline="0" dirty="0">
-                <a:ln>
-                  <a:noFill/>
-                </a:ln>
-                <a:solidFill>
-                  <a:schemeClr val="tx1"/>
-                </a:solidFill>
-                <a:effectLst/>
-              </a:rPr>
-              <a:t>) und </a:t>
-            </a:r>
-            <a:r>
-              <a:rPr kumimoji="0" lang="de-DE" altLang="de-DE" sz="1000" b="0" i="0" u="none" strike="noStrike" cap="none" normalizeH="0" baseline="0" dirty="0">
-                <a:ln>
-                  <a:noFill/>
-                </a:ln>
-                <a:solidFill>
-                  <a:schemeClr val="tx1"/>
-                </a:solidFill>
-                <a:effectLst/>
-                <a:latin typeface="Arial Unicode MS"/>
-              </a:rPr>
-              <a:t>DEFAULT</a:t>
-            </a:r>
-            <a:r>
-              <a:rPr kumimoji="0" lang="de-DE" altLang="de-DE" sz="800" b="0" i="0" u="none" strike="noStrike" cap="none" normalizeH="0" baseline="0" dirty="0">
-                <a:ln>
-                  <a:noFill/>
-                </a:ln>
-                <a:solidFill>
-                  <a:schemeClr val="tx1"/>
-                </a:solidFill>
-                <a:effectLst/>
-              </a:rPr>
-              <a:t>.</a:t>
-            </a:r>
-            <a:endParaRPr kumimoji="0" lang="de-DE" altLang="de-DE" sz="1800" b="0" i="0" u="none" strike="noStrike" cap="none" normalizeH="0" baseline="0" dirty="0">
-              <a:ln>
-                <a:noFill/>
-              </a:ln>
-              <a:solidFill>
-                <a:schemeClr val="tx1"/>
-              </a:solidFill>
-              <a:effectLst/>
-              <a:latin typeface="Arial" panose="020B0604020202020204" pitchFamily="34" charset="0"/>
-            </a:endParaRPr>
-          </a:p>
-        </p:txBody>
-      </p:sp>
+      </p:pic>
+      <p:pic>
+        <p:nvPicPr>
+          <p:cNvPr id="7" name="Grafik 6">
+            <a:extLst>
+              <a:ext uri="{FF2B5EF4-FFF2-40B4-BE49-F238E27FC236}">
+                <a16:creationId xmlns:a16="http://schemas.microsoft.com/office/drawing/2014/main" id="{7987BEE8-8A8E-4C6A-8367-6C5816CA5821}"/>
+              </a:ext>
+            </a:extLst>
+          </p:cNvPr>
+          <p:cNvPicPr>
+            <a:picLocks noChangeAspect="1"/>
+          </p:cNvPicPr>
+          <p:nvPr/>
+        </p:nvPicPr>
+        <p:blipFill>
+          <a:blip r:embed="rId3"/>
+          <a:stretch>
+            <a:fillRect/>
+          </a:stretch>
+        </p:blipFill>
+        <p:spPr>
+          <a:xfrm>
+            <a:off x="486827" y="4338320"/>
+            <a:ext cx="8520709" cy="2355030"/>
+          </a:xfrm>
+          <a:prstGeom prst="rect">
+            <a:avLst/>
+          </a:prstGeom>
+        </p:spPr>
+      </p:pic>
+      <mc:AlternateContent xmlns:mc="http://schemas.openxmlformats.org/markup-compatibility/2006">
+        <mc:Choice xmlns:p14="http://schemas.microsoft.com/office/powerpoint/2010/main" Requires="p14">
+          <p:contentPart p14:bwMode="auto" r:id="rId4">
+            <p14:nvContentPartPr>
+              <p14:cNvPr id="15" name="Freihand 14">
+                <a:extLst>
+                  <a:ext uri="{FF2B5EF4-FFF2-40B4-BE49-F238E27FC236}">
+                    <a16:creationId xmlns:a16="http://schemas.microsoft.com/office/drawing/2014/main" id="{8DA48645-239C-193A-1152-BDB47D670709}"/>
+                  </a:ext>
+                </a:extLst>
+              </p14:cNvPr>
+              <p14:cNvContentPartPr/>
+              <p14:nvPr/>
+            </p14:nvContentPartPr>
+            <p14:xfrm>
+              <a:off x="8554560" y="1016080"/>
+              <a:ext cx="360" cy="360"/>
+            </p14:xfrm>
+          </p:contentPart>
+        </mc:Choice>
+        <mc:Fallback>
+          <p:pic>
+            <p:nvPicPr>
+              <p:cNvPr id="15" name="Freihand 14">
+                <a:extLst>
+                  <a:ext uri="{FF2B5EF4-FFF2-40B4-BE49-F238E27FC236}">
+                    <a16:creationId xmlns:a16="http://schemas.microsoft.com/office/drawing/2014/main" id="{8DA48645-239C-193A-1152-BDB47D670709}"/>
+                  </a:ext>
+                </a:extLst>
+              </p:cNvPr>
+              <p:cNvPicPr/>
+              <p:nvPr/>
+            </p:nvPicPr>
+            <p:blipFill>
+              <a:blip r:embed="rId5"/>
+              <a:stretch>
+                <a:fillRect/>
+              </a:stretch>
+            </p:blipFill>
+            <p:spPr>
+              <a:xfrm>
+                <a:off x="8500560" y="908080"/>
+                <a:ext cx="108000" cy="216000"/>
+              </a:xfrm>
+              <a:prstGeom prst="rect">
+                <a:avLst/>
+              </a:prstGeom>
+            </p:spPr>
+          </p:pic>
+        </mc:Fallback>
+      </mc:AlternateContent>
+      <mc:AlternateContent xmlns:mc="http://schemas.openxmlformats.org/markup-compatibility/2006">
+        <mc:Choice xmlns:p14="http://schemas.microsoft.com/office/powerpoint/2010/main" Requires="p14">
+          <p:contentPart p14:bwMode="auto" r:id="rId6">
+            <p14:nvContentPartPr>
+              <p14:cNvPr id="16" name="Freihand 15">
+                <a:extLst>
+                  <a:ext uri="{FF2B5EF4-FFF2-40B4-BE49-F238E27FC236}">
+                    <a16:creationId xmlns:a16="http://schemas.microsoft.com/office/drawing/2014/main" id="{0BE1A261-C9DF-D027-0E4D-BEF3F2D2AD4D}"/>
+                  </a:ext>
+                </a:extLst>
+              </p14:cNvPr>
+              <p14:cNvContentPartPr/>
+              <p14:nvPr/>
+            </p14:nvContentPartPr>
+            <p14:xfrm>
+              <a:off x="2316480" y="2762080"/>
+              <a:ext cx="1167840" cy="52560"/>
+            </p14:xfrm>
+          </p:contentPart>
+        </mc:Choice>
+        <mc:Fallback>
+          <p:pic>
+            <p:nvPicPr>
+              <p:cNvPr id="16" name="Freihand 15">
+                <a:extLst>
+                  <a:ext uri="{FF2B5EF4-FFF2-40B4-BE49-F238E27FC236}">
+                    <a16:creationId xmlns:a16="http://schemas.microsoft.com/office/drawing/2014/main" id="{0BE1A261-C9DF-D027-0E4D-BEF3F2D2AD4D}"/>
+                  </a:ext>
+                </a:extLst>
+              </p:cNvPr>
+              <p:cNvPicPr/>
+              <p:nvPr/>
+            </p:nvPicPr>
+            <p:blipFill>
+              <a:blip r:embed="rId7"/>
+              <a:stretch>
+                <a:fillRect/>
+              </a:stretch>
+            </p:blipFill>
+            <p:spPr>
+              <a:xfrm>
+                <a:off x="2262480" y="2654080"/>
+                <a:ext cx="1275480" cy="268200"/>
+              </a:xfrm>
+              <a:prstGeom prst="rect">
+                <a:avLst/>
+              </a:prstGeom>
+            </p:spPr>
+          </p:pic>
+        </mc:Fallback>
+      </mc:AlternateContent>
+      <mc:AlternateContent xmlns:mc="http://schemas.openxmlformats.org/markup-compatibility/2006">
+        <mc:Choice xmlns:p14="http://schemas.microsoft.com/office/powerpoint/2010/main" Requires="p14">
+          <p:contentPart p14:bwMode="auto" r:id="rId8">
+            <p14:nvContentPartPr>
+              <p14:cNvPr id="17" name="Freihand 16">
+                <a:extLst>
+                  <a:ext uri="{FF2B5EF4-FFF2-40B4-BE49-F238E27FC236}">
+                    <a16:creationId xmlns:a16="http://schemas.microsoft.com/office/drawing/2014/main" id="{324C921B-ABBB-EF76-C01F-AE9136D4258B}"/>
+                  </a:ext>
+                </a:extLst>
+              </p14:cNvPr>
+              <p14:cNvContentPartPr/>
+              <p14:nvPr/>
+            </p14:nvContentPartPr>
+            <p14:xfrm>
+              <a:off x="2164200" y="3383440"/>
+              <a:ext cx="360" cy="360"/>
+            </p14:xfrm>
+          </p:contentPart>
+        </mc:Choice>
+        <mc:Fallback>
+          <p:pic>
+            <p:nvPicPr>
+              <p:cNvPr id="17" name="Freihand 16">
+                <a:extLst>
+                  <a:ext uri="{FF2B5EF4-FFF2-40B4-BE49-F238E27FC236}">
+                    <a16:creationId xmlns:a16="http://schemas.microsoft.com/office/drawing/2014/main" id="{324C921B-ABBB-EF76-C01F-AE9136D4258B}"/>
+                  </a:ext>
+                </a:extLst>
+              </p:cNvPr>
+              <p:cNvPicPr/>
+              <p:nvPr/>
+            </p:nvPicPr>
+            <p:blipFill>
+              <a:blip r:embed="rId9"/>
+              <a:stretch>
+                <a:fillRect/>
+              </a:stretch>
+            </p:blipFill>
+            <p:spPr>
+              <a:xfrm>
+                <a:off x="2110200" y="3275440"/>
+                <a:ext cx="108000" cy="216000"/>
+              </a:xfrm>
+              <a:prstGeom prst="rect">
+                <a:avLst/>
+              </a:prstGeom>
+            </p:spPr>
+          </p:pic>
+        </mc:Fallback>
+      </mc:AlternateContent>
+      <mc:AlternateContent xmlns:mc="http://schemas.openxmlformats.org/markup-compatibility/2006">
+        <mc:Choice xmlns:p14="http://schemas.microsoft.com/office/powerpoint/2010/main" Requires="p14">
+          <p:contentPart p14:bwMode="auto" r:id="rId10">
+            <p14:nvContentPartPr>
+              <p14:cNvPr id="18" name="Freihand 17">
+                <a:extLst>
+                  <a:ext uri="{FF2B5EF4-FFF2-40B4-BE49-F238E27FC236}">
+                    <a16:creationId xmlns:a16="http://schemas.microsoft.com/office/drawing/2014/main" id="{28C56EC4-0682-9137-4830-4D0549264010}"/>
+                  </a:ext>
+                </a:extLst>
+              </p14:cNvPr>
+              <p14:cNvContentPartPr/>
+              <p14:nvPr/>
+            </p14:nvContentPartPr>
+            <p14:xfrm>
+              <a:off x="2286240" y="2742280"/>
+              <a:ext cx="1315440" cy="72720"/>
+            </p14:xfrm>
+          </p:contentPart>
+        </mc:Choice>
+        <mc:Fallback>
+          <p:pic>
+            <p:nvPicPr>
+              <p:cNvPr id="18" name="Freihand 17">
+                <a:extLst>
+                  <a:ext uri="{FF2B5EF4-FFF2-40B4-BE49-F238E27FC236}">
+                    <a16:creationId xmlns:a16="http://schemas.microsoft.com/office/drawing/2014/main" id="{28C56EC4-0682-9137-4830-4D0549264010}"/>
+                  </a:ext>
+                </a:extLst>
+              </p:cNvPr>
+              <p:cNvPicPr/>
+              <p:nvPr/>
+            </p:nvPicPr>
+            <p:blipFill>
+              <a:blip r:embed="rId11"/>
+              <a:stretch>
+                <a:fillRect/>
+              </a:stretch>
+            </p:blipFill>
+            <p:spPr>
+              <a:xfrm>
+                <a:off x="2232240" y="2634280"/>
+                <a:ext cx="1423080" cy="288360"/>
+              </a:xfrm>
+              <a:prstGeom prst="rect">
+                <a:avLst/>
+              </a:prstGeom>
+            </p:spPr>
+          </p:pic>
+        </mc:Fallback>
+      </mc:AlternateContent>
+      <mc:AlternateContent xmlns:mc="http://schemas.openxmlformats.org/markup-compatibility/2006">
+        <mc:Choice xmlns:p14="http://schemas.microsoft.com/office/powerpoint/2010/main" Requires="p14">
+          <p:contentPart p14:bwMode="auto" r:id="rId12">
+            <p14:nvContentPartPr>
+              <p14:cNvPr id="19" name="Freihand 18">
+                <a:extLst>
+                  <a:ext uri="{FF2B5EF4-FFF2-40B4-BE49-F238E27FC236}">
+                    <a16:creationId xmlns:a16="http://schemas.microsoft.com/office/drawing/2014/main" id="{271AA6B5-2E49-A87E-65A6-C415124A7327}"/>
+                  </a:ext>
+                </a:extLst>
+              </p14:cNvPr>
+              <p14:cNvContentPartPr/>
+              <p14:nvPr/>
+            </p14:nvContentPartPr>
+            <p14:xfrm>
+              <a:off x="2610960" y="2854600"/>
+              <a:ext cx="920160" cy="10800"/>
+            </p14:xfrm>
+          </p:contentPart>
+        </mc:Choice>
+        <mc:Fallback>
+          <p:pic>
+            <p:nvPicPr>
+              <p:cNvPr id="19" name="Freihand 18">
+                <a:extLst>
+                  <a:ext uri="{FF2B5EF4-FFF2-40B4-BE49-F238E27FC236}">
+                    <a16:creationId xmlns:a16="http://schemas.microsoft.com/office/drawing/2014/main" id="{271AA6B5-2E49-A87E-65A6-C415124A7327}"/>
+                  </a:ext>
+                </a:extLst>
+              </p:cNvPr>
+              <p:cNvPicPr/>
+              <p:nvPr/>
+            </p:nvPicPr>
+            <p:blipFill>
+              <a:blip r:embed="rId13"/>
+              <a:stretch>
+                <a:fillRect/>
+              </a:stretch>
+            </p:blipFill>
+            <p:spPr>
+              <a:xfrm>
+                <a:off x="2557320" y="2746600"/>
+                <a:ext cx="1027800" cy="226440"/>
+              </a:xfrm>
+              <a:prstGeom prst="rect">
+                <a:avLst/>
+              </a:prstGeom>
+            </p:spPr>
+          </p:pic>
+        </mc:Fallback>
+      </mc:AlternateContent>
+      <mc:AlternateContent xmlns:mc="http://schemas.openxmlformats.org/markup-compatibility/2006">
+        <mc:Choice xmlns:p14="http://schemas.microsoft.com/office/powerpoint/2010/main" Requires="p14">
+          <p:contentPart p14:bwMode="auto" r:id="rId14">
+            <p14:nvContentPartPr>
+              <p14:cNvPr id="20" name="Freihand 19">
+                <a:extLst>
+                  <a:ext uri="{FF2B5EF4-FFF2-40B4-BE49-F238E27FC236}">
+                    <a16:creationId xmlns:a16="http://schemas.microsoft.com/office/drawing/2014/main" id="{0604E035-1F46-FE54-3751-BB789110F7D0}"/>
+                  </a:ext>
+                </a:extLst>
+              </p14:cNvPr>
+              <p14:cNvContentPartPr/>
+              <p14:nvPr/>
+            </p14:nvContentPartPr>
+            <p14:xfrm>
+              <a:off x="2123520" y="5017480"/>
+              <a:ext cx="1449720" cy="113400"/>
+            </p14:xfrm>
+          </p:contentPart>
+        </mc:Choice>
+        <mc:Fallback>
+          <p:pic>
+            <p:nvPicPr>
+              <p:cNvPr id="20" name="Freihand 19">
+                <a:extLst>
+                  <a:ext uri="{FF2B5EF4-FFF2-40B4-BE49-F238E27FC236}">
+                    <a16:creationId xmlns:a16="http://schemas.microsoft.com/office/drawing/2014/main" id="{0604E035-1F46-FE54-3751-BB789110F7D0}"/>
+                  </a:ext>
+                </a:extLst>
+              </p:cNvPr>
+              <p:cNvPicPr/>
+              <p:nvPr/>
+            </p:nvPicPr>
+            <p:blipFill>
+              <a:blip r:embed="rId15"/>
+              <a:stretch>
+                <a:fillRect/>
+              </a:stretch>
+            </p:blipFill>
+            <p:spPr>
+              <a:xfrm>
+                <a:off x="2069520" y="4909840"/>
+                <a:ext cx="1557360" cy="329040"/>
+              </a:xfrm>
+              <a:prstGeom prst="rect">
+                <a:avLst/>
+              </a:prstGeom>
+            </p:spPr>
+          </p:pic>
+        </mc:Fallback>
+      </mc:AlternateContent>
+      <mc:AlternateContent xmlns:mc="http://schemas.openxmlformats.org/markup-compatibility/2006">
+        <mc:Choice xmlns:p14="http://schemas.microsoft.com/office/powerpoint/2010/main" Requires="p14">
+          <p:contentPart p14:bwMode="auto" r:id="rId16">
+            <p14:nvContentPartPr>
+              <p14:cNvPr id="21" name="Freihand 20">
+                <a:extLst>
+                  <a:ext uri="{FF2B5EF4-FFF2-40B4-BE49-F238E27FC236}">
+                    <a16:creationId xmlns:a16="http://schemas.microsoft.com/office/drawing/2014/main" id="{772323C3-BAC6-2471-8A58-49C50B9F208B}"/>
+                  </a:ext>
+                </a:extLst>
+              </p14:cNvPr>
+              <p14:cNvContentPartPr/>
+              <p14:nvPr/>
+            </p14:nvContentPartPr>
+            <p14:xfrm>
+              <a:off x="2367240" y="5142040"/>
+              <a:ext cx="1173600" cy="90720"/>
+            </p14:xfrm>
+          </p:contentPart>
+        </mc:Choice>
+        <mc:Fallback>
+          <p:pic>
+            <p:nvPicPr>
+              <p:cNvPr id="21" name="Freihand 20">
+                <a:extLst>
+                  <a:ext uri="{FF2B5EF4-FFF2-40B4-BE49-F238E27FC236}">
+                    <a16:creationId xmlns:a16="http://schemas.microsoft.com/office/drawing/2014/main" id="{772323C3-BAC6-2471-8A58-49C50B9F208B}"/>
+                  </a:ext>
+                </a:extLst>
+              </p:cNvPr>
+              <p:cNvPicPr/>
+              <p:nvPr/>
+            </p:nvPicPr>
+            <p:blipFill>
+              <a:blip r:embed="rId17"/>
+              <a:stretch>
+                <a:fillRect/>
+              </a:stretch>
+            </p:blipFill>
+            <p:spPr>
+              <a:xfrm>
+                <a:off x="2313240" y="5034400"/>
+                <a:ext cx="1281240" cy="306360"/>
+              </a:xfrm>
+              <a:prstGeom prst="rect">
+                <a:avLst/>
+              </a:prstGeom>
+            </p:spPr>
+          </p:pic>
+        </mc:Fallback>
+      </mc:AlternateContent>
+      <mc:AlternateContent xmlns:mc="http://schemas.openxmlformats.org/markup-compatibility/2006">
+        <mc:Choice xmlns:p14="http://schemas.microsoft.com/office/powerpoint/2010/main" Requires="p14">
+          <p:contentPart p14:bwMode="auto" r:id="rId18">
+            <p14:nvContentPartPr>
+              <p14:cNvPr id="22" name="Freihand 21">
+                <a:extLst>
+                  <a:ext uri="{FF2B5EF4-FFF2-40B4-BE49-F238E27FC236}">
+                    <a16:creationId xmlns:a16="http://schemas.microsoft.com/office/drawing/2014/main" id="{EC5CCC04-F7F7-2A5F-FF42-EE2C31DE9CA2}"/>
+                  </a:ext>
+                </a:extLst>
+              </p14:cNvPr>
+              <p14:cNvContentPartPr/>
+              <p14:nvPr/>
+            </p14:nvContentPartPr>
+            <p14:xfrm>
+              <a:off x="2214600" y="5151760"/>
+              <a:ext cx="1571760" cy="72000"/>
+            </p14:xfrm>
+          </p:contentPart>
+        </mc:Choice>
+        <mc:Fallback>
+          <p:pic>
+            <p:nvPicPr>
+              <p:cNvPr id="22" name="Freihand 21">
+                <a:extLst>
+                  <a:ext uri="{FF2B5EF4-FFF2-40B4-BE49-F238E27FC236}">
+                    <a16:creationId xmlns:a16="http://schemas.microsoft.com/office/drawing/2014/main" id="{EC5CCC04-F7F7-2A5F-FF42-EE2C31DE9CA2}"/>
+                  </a:ext>
+                </a:extLst>
+              </p:cNvPr>
+              <p:cNvPicPr/>
+              <p:nvPr/>
+            </p:nvPicPr>
+            <p:blipFill>
+              <a:blip r:embed="rId19"/>
+              <a:stretch>
+                <a:fillRect/>
+              </a:stretch>
+            </p:blipFill>
+            <p:spPr>
+              <a:xfrm>
+                <a:off x="2160600" y="5043760"/>
+                <a:ext cx="1679400" cy="287640"/>
+              </a:xfrm>
+              <a:prstGeom prst="rect">
+                <a:avLst/>
+              </a:prstGeom>
+            </p:spPr>
+          </p:pic>
+        </mc:Fallback>
+      </mc:AlternateContent>
+      <mc:AlternateContent xmlns:mc="http://schemas.openxmlformats.org/markup-compatibility/2006">
+        <mc:Choice xmlns:p14="http://schemas.microsoft.com/office/powerpoint/2010/main" Requires="p14">
+          <p:contentPart p14:bwMode="auto" r:id="rId20">
+            <p14:nvContentPartPr>
+              <p14:cNvPr id="23" name="Freihand 22">
+                <a:extLst>
+                  <a:ext uri="{FF2B5EF4-FFF2-40B4-BE49-F238E27FC236}">
+                    <a16:creationId xmlns:a16="http://schemas.microsoft.com/office/drawing/2014/main" id="{3F6B21F7-BD55-8644-8487-14FB5EAE61F0}"/>
+                  </a:ext>
+                </a:extLst>
+              </p14:cNvPr>
+              <p14:cNvContentPartPr/>
+              <p14:nvPr/>
+            </p14:nvContentPartPr>
+            <p14:xfrm>
+              <a:off x="2255280" y="5142040"/>
+              <a:ext cx="1442880" cy="100800"/>
+            </p14:xfrm>
+          </p:contentPart>
+        </mc:Choice>
+        <mc:Fallback>
+          <p:pic>
+            <p:nvPicPr>
+              <p:cNvPr id="23" name="Freihand 22">
+                <a:extLst>
+                  <a:ext uri="{FF2B5EF4-FFF2-40B4-BE49-F238E27FC236}">
+                    <a16:creationId xmlns:a16="http://schemas.microsoft.com/office/drawing/2014/main" id="{3F6B21F7-BD55-8644-8487-14FB5EAE61F0}"/>
+                  </a:ext>
+                </a:extLst>
+              </p:cNvPr>
+              <p:cNvPicPr/>
+              <p:nvPr/>
+            </p:nvPicPr>
+            <p:blipFill>
+              <a:blip r:embed="rId21"/>
+              <a:stretch>
+                <a:fillRect/>
+              </a:stretch>
+            </p:blipFill>
+            <p:spPr>
+              <a:xfrm>
+                <a:off x="2201640" y="5034040"/>
+                <a:ext cx="1550520" cy="316440"/>
+              </a:xfrm>
+              <a:prstGeom prst="rect">
+                <a:avLst/>
+              </a:prstGeom>
+            </p:spPr>
+          </p:pic>
+        </mc:Fallback>
+      </mc:AlternateContent>
     </p:spTree>
     <p:extLst>
       <p:ext uri="{BB962C8B-B14F-4D97-AF65-F5344CB8AC3E}">
@@ -14513,6 +15033,10 @@
           </p:nvPr>
         </p:nvSpPr>
         <p:spPr bwMode="auto">
+          <a:xfrm>
+            <a:off x="913775" y="3755981"/>
+            <a:ext cx="11044627" cy="646331"/>
+          </a:xfrm>
           <a:prstGeom prst="rect">
             <a:avLst/>
           </a:prstGeom>
@@ -14602,7 +15126,7 @@
               <a:t> </a:t>
             </a:r>
             <a:r>
-              <a:rPr kumimoji="0" lang="de-DE" altLang="de-DE" sz="1000" b="0" i="0" u="none" strike="noStrike" cap="none" normalizeH="0" baseline="0" dirty="0">
+              <a:rPr kumimoji="0" lang="de-DE" altLang="de-DE" sz="1800" b="0" i="0" u="none" strike="noStrike" cap="none" normalizeH="0" baseline="0" dirty="0">
                 <a:ln>
                   <a:noFill/>
                 </a:ln>
@@ -14615,7 +15139,7 @@
               <a:t>UNIQUE (</a:t>
             </a:r>
             <a:r>
-              <a:rPr kumimoji="0" lang="de-DE" altLang="de-DE" sz="1000" b="0" i="0" u="none" strike="noStrike" cap="none" normalizeH="0" baseline="0" dirty="0" err="1">
+              <a:rPr kumimoji="0" lang="de-DE" altLang="de-DE" sz="1800" b="0" i="0" u="none" strike="noStrike" cap="none" normalizeH="0" baseline="0" dirty="0" err="1">
                 <a:ln>
                   <a:noFill/>
                 </a:ln>
@@ -14628,7 +15152,7 @@
               <a:t>ean_code</a:t>
             </a:r>
             <a:r>
-              <a:rPr kumimoji="0" lang="de-DE" altLang="de-DE" sz="1000" b="0" i="0" u="none" strike="noStrike" cap="none" normalizeH="0" baseline="0" dirty="0">
+              <a:rPr kumimoji="0" lang="de-DE" altLang="de-DE" sz="1800" b="0" i="0" u="none" strike="noStrike" cap="none" normalizeH="0" baseline="0" dirty="0">
                 <a:ln>
                   <a:noFill/>
                 </a:ln>
@@ -14641,7 +15165,7 @@
               <a:t>)</a:t>
             </a:r>
             <a:r>
-              <a:rPr kumimoji="0" lang="de-DE" altLang="de-DE" sz="800" b="0" i="0" u="none" strike="noStrike" cap="none" normalizeH="0" baseline="0" dirty="0">
+              <a:rPr kumimoji="0" lang="de-DE" altLang="de-DE" sz="1800" b="0" i="0" u="none" strike="noStrike" cap="none" normalizeH="0" baseline="0" dirty="0">
                 <a:ln>
                   <a:noFill/>
                 </a:ln>
@@ -14653,7 +15177,7 @@
               <a:t>, </a:t>
             </a:r>
             <a:r>
-              <a:rPr kumimoji="0" lang="de-DE" altLang="de-DE" sz="1000" b="0" i="0" u="none" strike="noStrike" cap="none" normalizeH="0" baseline="0" dirty="0">
+              <a:rPr kumimoji="0" lang="de-DE" altLang="de-DE" sz="1800" b="0" i="0" u="none" strike="noStrike" cap="none" normalizeH="0" baseline="0" dirty="0">
                 <a:ln>
                   <a:noFill/>
                 </a:ln>
@@ -14666,7 +15190,7 @@
               <a:t>CHECK (</a:t>
             </a:r>
             <a:r>
-              <a:rPr kumimoji="0" lang="de-DE" altLang="de-DE" sz="1000" b="0" i="0" u="none" strike="noStrike" cap="none" normalizeH="0" baseline="0" dirty="0" err="1">
+              <a:rPr kumimoji="0" lang="de-DE" altLang="de-DE" sz="1800" b="0" i="0" u="none" strike="noStrike" cap="none" normalizeH="0" baseline="0" dirty="0" err="1">
                 <a:ln>
                   <a:noFill/>
                 </a:ln>
@@ -14679,7 +15203,7 @@
               <a:t>altersfreigabe</a:t>
             </a:r>
             <a:r>
-              <a:rPr kumimoji="0" lang="de-DE" altLang="de-DE" sz="1000" b="0" i="0" u="none" strike="noStrike" cap="none" normalizeH="0" baseline="0" dirty="0">
+              <a:rPr kumimoji="0" lang="de-DE" altLang="de-DE" sz="1800" b="0" i="0" u="none" strike="noStrike" cap="none" normalizeH="0" baseline="0" dirty="0">
                 <a:ln>
                   <a:noFill/>
                 </a:ln>
@@ -14692,7 +15216,7 @@
               <a:t> IN (0,16,18))</a:t>
             </a:r>
             <a:r>
-              <a:rPr kumimoji="0" lang="de-DE" altLang="de-DE" sz="800" b="0" i="0" u="none" strike="noStrike" cap="none" normalizeH="0" baseline="0" dirty="0">
+              <a:rPr kumimoji="0" lang="de-DE" altLang="de-DE" sz="1800" b="0" i="0" u="none" strike="noStrike" cap="none" normalizeH="0" baseline="0" dirty="0">
                 <a:ln>
                   <a:noFill/>
                 </a:ln>
@@ -14704,7 +15228,7 @@
               <a:t>, Alter berechnet via </a:t>
             </a:r>
             <a:r>
-              <a:rPr kumimoji="0" lang="de-DE" altLang="de-DE" sz="1000" b="0" i="0" u="none" strike="noStrike" cap="none" normalizeH="0" baseline="0" dirty="0" err="1">
+              <a:rPr kumimoji="0" lang="de-DE" altLang="de-DE" sz="1800" b="0" i="0" u="none" strike="noStrike" cap="none" normalizeH="0" baseline="0" dirty="0" err="1">
                 <a:ln>
                   <a:noFill/>
                 </a:ln>
@@ -14717,7 +15241,7 @@
               <a:t>geburtsdatum</a:t>
             </a:r>
             <a:r>
-              <a:rPr kumimoji="0" lang="de-DE" altLang="de-DE" sz="800" b="0" i="0" u="none" strike="noStrike" cap="none" normalizeH="0" baseline="0" dirty="0">
+              <a:rPr kumimoji="0" lang="de-DE" altLang="de-DE" sz="1800" b="0" i="0" u="none" strike="noStrike" cap="none" normalizeH="0" baseline="0" dirty="0">
                 <a:ln>
                   <a:noFill/>
                 </a:ln>

</xml_diff>

<commit_message>
dokumente laut raab abi überarbeitet
</commit_message>
<xml_diff>
--- a/docs/Präsentation1803.pptx
+++ b/docs/Präsentation1803.pptx
@@ -1063,10 +1063,18 @@
             </a:lnSpc>
           </a:pPr>
           <a:r>
-            <a:rPr lang="de-DE" b="0" i="0" baseline="0"/>
-            <a:t>Schnelle und fehlerfreie Erfassung am Point of Sale (Kassensystem).</a:t>
+            <a:rPr lang="de-DE" b="0" i="0" baseline="0" dirty="0"/>
+            <a:t>Schnelle und fehlerfreie Erfassung am Point </a:t>
           </a:r>
-          <a:endParaRPr lang="en-US"/>
+          <a:r>
+            <a:rPr lang="de-DE" b="0" i="0" baseline="0" dirty="0" err="1"/>
+            <a:t>of</a:t>
+          </a:r>
+          <a:r>
+            <a:rPr lang="de-DE" b="0" i="0" baseline="0" dirty="0"/>
+            <a:t> Sale (Kassensystem).</a:t>
+          </a:r>
+          <a:endParaRPr lang="en-US" dirty="0"/>
         </a:p>
       </dgm:t>
     </dgm:pt>
@@ -1239,13 +1247,13 @@
       <dgm:prSet presAssocID="{50580707-3425-4014-90D4-195B14FBC168}" presName="iconRect" presStyleLbl="node1" presStyleIdx="0" presStyleCnt="4"/>
       <dgm:spPr>
         <a:blipFill>
-          <a:blip xmlns:r="http://schemas.openxmlformats.org/officeDocument/2006/relationships" r:embed="rId1">
+          <a:blip xmlns:r="http://schemas.openxmlformats.org/officeDocument/2006/relationships">
             <a:extLst>
               <a:ext uri="{28A0092B-C50C-407E-A947-70E740481C1C}">
                 <a14:useLocalDpi xmlns:a14="http://schemas.microsoft.com/office/drawing/2010/main" val="0"/>
               </a:ext>
               <a:ext uri="{96DAC541-7B7A-43D3-8B79-37D633B846F1}">
-                <asvg:svgBlip xmlns:asvg="http://schemas.microsoft.com/office/drawing/2016/SVG/main" r:embed="rId2"/>
+                <asvg:svgBlip xmlns:asvg="http://schemas.microsoft.com/office/drawing/2016/SVG/main" r:embed="rId1"/>
               </a:ext>
             </a:extLst>
           </a:blip>
@@ -1292,13 +1300,13 @@
       <dgm:prSet presAssocID="{31D1528E-28EF-46A9-B0C0-10FB3C7DC716}" presName="iconRect" presStyleLbl="node1" presStyleIdx="1" presStyleCnt="4"/>
       <dgm:spPr>
         <a:blipFill>
-          <a:blip xmlns:r="http://schemas.openxmlformats.org/officeDocument/2006/relationships" r:embed="rId3">
+          <a:blip xmlns:r="http://schemas.openxmlformats.org/officeDocument/2006/relationships">
             <a:extLst>
               <a:ext uri="{28A0092B-C50C-407E-A947-70E740481C1C}">
                 <a14:useLocalDpi xmlns:a14="http://schemas.microsoft.com/office/drawing/2010/main" val="0"/>
               </a:ext>
               <a:ext uri="{96DAC541-7B7A-43D3-8B79-37D633B846F1}">
-                <asvg:svgBlip xmlns:asvg="http://schemas.microsoft.com/office/drawing/2016/SVG/main" r:embed="rId4"/>
+                <asvg:svgBlip xmlns:asvg="http://schemas.microsoft.com/office/drawing/2016/SVG/main" r:embed="rId2"/>
               </a:ext>
             </a:extLst>
           </a:blip>
@@ -1345,13 +1353,13 @@
       <dgm:prSet presAssocID="{00C2E301-8CC6-4F26-AD3F-9D1842139C8B}" presName="iconRect" presStyleLbl="node1" presStyleIdx="2" presStyleCnt="4"/>
       <dgm:spPr>
         <a:blipFill>
-          <a:blip xmlns:r="http://schemas.openxmlformats.org/officeDocument/2006/relationships" r:embed="rId5">
+          <a:blip xmlns:r="http://schemas.openxmlformats.org/officeDocument/2006/relationships">
             <a:extLst>
               <a:ext uri="{28A0092B-C50C-407E-A947-70E740481C1C}">
                 <a14:useLocalDpi xmlns:a14="http://schemas.microsoft.com/office/drawing/2010/main" val="0"/>
               </a:ext>
               <a:ext uri="{96DAC541-7B7A-43D3-8B79-37D633B846F1}">
-                <asvg:svgBlip xmlns:asvg="http://schemas.microsoft.com/office/drawing/2016/SVG/main" r:embed="rId6"/>
+                <asvg:svgBlip xmlns:asvg="http://schemas.microsoft.com/office/drawing/2016/SVG/main" r:embed="rId3"/>
               </a:ext>
             </a:extLst>
           </a:blip>
@@ -1398,13 +1406,13 @@
       <dgm:prSet presAssocID="{82A6D22E-AD37-4035-AF27-B2EAE0AC64A2}" presName="iconRect" presStyleLbl="node1" presStyleIdx="3" presStyleCnt="4"/>
       <dgm:spPr>
         <a:blipFill>
-          <a:blip xmlns:r="http://schemas.openxmlformats.org/officeDocument/2006/relationships" r:embed="rId7">
+          <a:blip xmlns:r="http://schemas.openxmlformats.org/officeDocument/2006/relationships">
             <a:extLst>
               <a:ext uri="{28A0092B-C50C-407E-A947-70E740481C1C}">
                 <a14:useLocalDpi xmlns:a14="http://schemas.microsoft.com/office/drawing/2010/main" val="0"/>
               </a:ext>
               <a:ext uri="{96DAC541-7B7A-43D3-8B79-37D633B846F1}">
-                <asvg:svgBlip xmlns:asvg="http://schemas.microsoft.com/office/drawing/2016/SVG/main" r:embed="rId8"/>
+                <asvg:svgBlip xmlns:asvg="http://schemas.microsoft.com/office/drawing/2016/SVG/main" r:embed="rId4"/>
               </a:ext>
             </a:extLst>
           </a:blip>
@@ -1544,13 +1552,13 @@
           <a:avLst/>
         </a:prstGeom>
         <a:blipFill>
-          <a:blip xmlns:r="http://schemas.openxmlformats.org/officeDocument/2006/relationships" r:embed="rId1">
+          <a:blip xmlns:r="http://schemas.openxmlformats.org/officeDocument/2006/relationships">
             <a:extLst>
               <a:ext uri="{28A0092B-C50C-407E-A947-70E740481C1C}">
                 <a14:useLocalDpi xmlns:a14="http://schemas.microsoft.com/office/drawing/2010/main" val="0"/>
               </a:ext>
               <a:ext uri="{96DAC541-7B7A-43D3-8B79-37D633B846F1}">
-                <asvg:svgBlip xmlns:asvg="http://schemas.microsoft.com/office/drawing/2016/SVG/main" r:embed="rId2"/>
+                <asvg:svgBlip xmlns:asvg="http://schemas.microsoft.com/office/drawing/2016/SVG/main" r:embed="rId1"/>
               </a:ext>
             </a:extLst>
           </a:blip>
@@ -1629,10 +1637,18 @@
             <a:buNone/>
           </a:pPr>
           <a:r>
-            <a:rPr lang="de-DE" sz="2200" b="0" i="0" kern="1200" baseline="0"/>
-            <a:t>Schnelle und fehlerfreie Erfassung am Point of Sale (Kassensystem).</a:t>
+            <a:rPr lang="de-DE" sz="2200" b="0" i="0" kern="1200" baseline="0" dirty="0"/>
+            <a:t>Schnelle und fehlerfreie Erfassung am Point </a:t>
           </a:r>
-          <a:endParaRPr lang="en-US" sz="2200" kern="1200"/>
+          <a:r>
+            <a:rPr lang="de-DE" sz="2200" b="0" i="0" kern="1200" baseline="0" dirty="0" err="1"/>
+            <a:t>of</a:t>
+          </a:r>
+          <a:r>
+            <a:rPr lang="de-DE" sz="2200" b="0" i="0" kern="1200" baseline="0" dirty="0"/>
+            <a:t> Sale (Kassensystem).</a:t>
+          </a:r>
+          <a:endParaRPr lang="en-US" sz="2200" kern="1200" dirty="0"/>
         </a:p>
       </dsp:txBody>
       <dsp:txXfrm>
@@ -1696,13 +1712,13 @@
           <a:avLst/>
         </a:prstGeom>
         <a:blipFill>
-          <a:blip xmlns:r="http://schemas.openxmlformats.org/officeDocument/2006/relationships" r:embed="rId3">
+          <a:blip xmlns:r="http://schemas.openxmlformats.org/officeDocument/2006/relationships">
             <a:extLst>
               <a:ext uri="{28A0092B-C50C-407E-A947-70E740481C1C}">
                 <a14:useLocalDpi xmlns:a14="http://schemas.microsoft.com/office/drawing/2010/main" val="0"/>
               </a:ext>
               <a:ext uri="{96DAC541-7B7A-43D3-8B79-37D633B846F1}">
-                <asvg:svgBlip xmlns:asvg="http://schemas.microsoft.com/office/drawing/2016/SVG/main" r:embed="rId4"/>
+                <asvg:svgBlip xmlns:asvg="http://schemas.microsoft.com/office/drawing/2016/SVG/main" r:embed="rId2"/>
               </a:ext>
             </a:extLst>
           </a:blip>
@@ -1848,13 +1864,13 @@
           <a:avLst/>
         </a:prstGeom>
         <a:blipFill>
-          <a:blip xmlns:r="http://schemas.openxmlformats.org/officeDocument/2006/relationships" r:embed="rId5">
+          <a:blip xmlns:r="http://schemas.openxmlformats.org/officeDocument/2006/relationships">
             <a:extLst>
               <a:ext uri="{28A0092B-C50C-407E-A947-70E740481C1C}">
                 <a14:useLocalDpi xmlns:a14="http://schemas.microsoft.com/office/drawing/2010/main" val="0"/>
               </a:ext>
               <a:ext uri="{96DAC541-7B7A-43D3-8B79-37D633B846F1}">
-                <asvg:svgBlip xmlns:asvg="http://schemas.microsoft.com/office/drawing/2016/SVG/main" r:embed="rId6"/>
+                <asvg:svgBlip xmlns:asvg="http://schemas.microsoft.com/office/drawing/2016/SVG/main" r:embed="rId3"/>
               </a:ext>
             </a:extLst>
           </a:blip>
@@ -2000,13 +2016,13 @@
           <a:avLst/>
         </a:prstGeom>
         <a:blipFill>
-          <a:blip xmlns:r="http://schemas.openxmlformats.org/officeDocument/2006/relationships" r:embed="rId7">
+          <a:blip xmlns:r="http://schemas.openxmlformats.org/officeDocument/2006/relationships">
             <a:extLst>
               <a:ext uri="{28A0092B-C50C-407E-A947-70E740481C1C}">
                 <a14:useLocalDpi xmlns:a14="http://schemas.microsoft.com/office/drawing/2010/main" val="0"/>
               </a:ext>
               <a:ext uri="{96DAC541-7B7A-43D3-8B79-37D633B846F1}">
-                <asvg:svgBlip xmlns:asvg="http://schemas.microsoft.com/office/drawing/2016/SVG/main" r:embed="rId8"/>
+                <asvg:svgBlip xmlns:asvg="http://schemas.microsoft.com/office/drawing/2016/SVG/main" r:embed="rId4"/>
               </a:ext>
             </a:extLst>
           </a:blip>
@@ -3599,7 +3615,7 @@
           <a:p>
             <a:fld id="{AB4A5B31-C8C7-4C22-B0E9-873766B6517D}" type="datetimeFigureOut">
               <a:rPr lang="de-DE" smtClean="0"/>
-              <a:t>18.03.2026</a:t>
+              <a:t>24.03.2026</a:t>
             </a:fld>
             <a:endParaRPr lang="de-DE"/>
           </a:p>
@@ -3911,7 +3927,7 @@
           <a:p>
             <a:fld id="{AB4A5B31-C8C7-4C22-B0E9-873766B6517D}" type="datetimeFigureOut">
               <a:rPr lang="de-DE" smtClean="0"/>
-              <a:t>18.03.2026</a:t>
+              <a:t>24.03.2026</a:t>
             </a:fld>
             <a:endParaRPr lang="de-DE"/>
           </a:p>
@@ -4133,7 +4149,7 @@
           <a:p>
             <a:fld id="{AB4A5B31-C8C7-4C22-B0E9-873766B6517D}" type="datetimeFigureOut">
               <a:rPr lang="de-DE" smtClean="0"/>
-              <a:t>18.03.2026</a:t>
+              <a:t>24.03.2026</a:t>
             </a:fld>
             <a:endParaRPr lang="de-DE"/>
           </a:p>
@@ -4424,7 +4440,7 @@
           <a:p>
             <a:fld id="{AB4A5B31-C8C7-4C22-B0E9-873766B6517D}" type="datetimeFigureOut">
               <a:rPr lang="de-DE" smtClean="0"/>
-              <a:t>18.03.2026</a:t>
+              <a:t>24.03.2026</a:t>
             </a:fld>
             <a:endParaRPr lang="de-DE"/>
           </a:p>
@@ -4878,7 +4894,7 @@
           <a:p>
             <a:fld id="{AB4A5B31-C8C7-4C22-B0E9-873766B6517D}" type="datetimeFigureOut">
               <a:rPr lang="de-DE" smtClean="0"/>
-              <a:t>18.03.2026</a:t>
+              <a:t>24.03.2026</a:t>
             </a:fld>
             <a:endParaRPr lang="de-DE"/>
           </a:p>
@@ -5454,7 +5470,7 @@
           <a:p>
             <a:fld id="{AB4A5B31-C8C7-4C22-B0E9-873766B6517D}" type="datetimeFigureOut">
               <a:rPr lang="de-DE" smtClean="0"/>
-              <a:t>18.03.2026</a:t>
+              <a:t>24.03.2026</a:t>
             </a:fld>
             <a:endParaRPr lang="de-DE"/>
           </a:p>
@@ -6306,7 +6322,7 @@
           <a:p>
             <a:fld id="{AB4A5B31-C8C7-4C22-B0E9-873766B6517D}" type="datetimeFigureOut">
               <a:rPr lang="de-DE" smtClean="0"/>
-              <a:t>18.03.2026</a:t>
+              <a:t>24.03.2026</a:t>
             </a:fld>
             <a:endParaRPr lang="de-DE"/>
           </a:p>
@@ -6511,7 +6527,7 @@
           <a:p>
             <a:fld id="{AB4A5B31-C8C7-4C22-B0E9-873766B6517D}" type="datetimeFigureOut">
               <a:rPr lang="de-DE" smtClean="0"/>
-              <a:t>18.03.2026</a:t>
+              <a:t>24.03.2026</a:t>
             </a:fld>
             <a:endParaRPr lang="de-DE"/>
           </a:p>
@@ -6725,7 +6741,7 @@
           <a:p>
             <a:fld id="{AB4A5B31-C8C7-4C22-B0E9-873766B6517D}" type="datetimeFigureOut">
               <a:rPr lang="de-DE" smtClean="0"/>
-              <a:t>18.03.2026</a:t>
+              <a:t>24.03.2026</a:t>
             </a:fld>
             <a:endParaRPr lang="de-DE"/>
           </a:p>
@@ -6895,7 +6911,7 @@
           <a:p>
             <a:fld id="{AB4A5B31-C8C7-4C22-B0E9-873766B6517D}" type="datetimeFigureOut">
               <a:rPr lang="de-DE" smtClean="0"/>
-              <a:t>18.03.2026</a:t>
+              <a:t>24.03.2026</a:t>
             </a:fld>
             <a:endParaRPr lang="de-DE"/>
           </a:p>
@@ -7100,7 +7116,7 @@
           <a:p>
             <a:fld id="{AB4A5B31-C8C7-4C22-B0E9-873766B6517D}" type="datetimeFigureOut">
               <a:rPr lang="de-DE" smtClean="0"/>
-              <a:t>18.03.2026</a:t>
+              <a:t>24.03.2026</a:t>
             </a:fld>
             <a:endParaRPr lang="de-DE"/>
           </a:p>
@@ -7380,7 +7396,7 @@
           <a:p>
             <a:fld id="{AB4A5B31-C8C7-4C22-B0E9-873766B6517D}" type="datetimeFigureOut">
               <a:rPr lang="de-DE" smtClean="0"/>
-              <a:t>18.03.2026</a:t>
+              <a:t>24.03.2026</a:t>
             </a:fld>
             <a:endParaRPr lang="de-DE"/>
           </a:p>
@@ -7647,7 +7663,7 @@
           <a:p>
             <a:fld id="{AB4A5B31-C8C7-4C22-B0E9-873766B6517D}" type="datetimeFigureOut">
               <a:rPr lang="de-DE" smtClean="0"/>
-              <a:t>18.03.2026</a:t>
+              <a:t>24.03.2026</a:t>
             </a:fld>
             <a:endParaRPr lang="de-DE"/>
           </a:p>
@@ -8062,7 +8078,7 @@
           <a:p>
             <a:fld id="{AB4A5B31-C8C7-4C22-B0E9-873766B6517D}" type="datetimeFigureOut">
               <a:rPr lang="de-DE" smtClean="0"/>
-              <a:t>18.03.2026</a:t>
+              <a:t>24.03.2026</a:t>
             </a:fld>
             <a:endParaRPr lang="de-DE"/>
           </a:p>
@@ -8210,7 +8226,7 @@
           <a:p>
             <a:fld id="{AB4A5B31-C8C7-4C22-B0E9-873766B6517D}" type="datetimeFigureOut">
               <a:rPr lang="de-DE" smtClean="0"/>
-              <a:t>18.03.2026</a:t>
+              <a:t>24.03.2026</a:t>
             </a:fld>
             <a:endParaRPr lang="de-DE"/>
           </a:p>
@@ -8335,7 +8351,7 @@
           <a:p>
             <a:fld id="{AB4A5B31-C8C7-4C22-B0E9-873766B6517D}" type="datetimeFigureOut">
               <a:rPr lang="de-DE" smtClean="0"/>
-              <a:t>18.03.2026</a:t>
+              <a:t>24.03.2026</a:t>
             </a:fld>
             <a:endParaRPr lang="de-DE"/>
           </a:p>
@@ -8614,7 +8630,7 @@
           <a:p>
             <a:fld id="{AB4A5B31-C8C7-4C22-B0E9-873766B6517D}" type="datetimeFigureOut">
               <a:rPr lang="de-DE" smtClean="0"/>
-              <a:t>18.03.2026</a:t>
+              <a:t>24.03.2026</a:t>
             </a:fld>
             <a:endParaRPr lang="de-DE"/>
           </a:p>
@@ -8926,7 +8942,7 @@
           <a:p>
             <a:fld id="{AB4A5B31-C8C7-4C22-B0E9-873766B6517D}" type="datetimeFigureOut">
               <a:rPr lang="de-DE" smtClean="0"/>
-              <a:t>18.03.2026</a:t>
+              <a:t>24.03.2026</a:t>
             </a:fld>
             <a:endParaRPr lang="de-DE"/>
           </a:p>
@@ -9179,7 +9195,7 @@
           <a:p>
             <a:fld id="{AB4A5B31-C8C7-4C22-B0E9-873766B6517D}" type="datetimeFigureOut">
               <a:rPr lang="de-DE" smtClean="0"/>
-              <a:t>18.03.2026</a:t>
+              <a:t>24.03.2026</a:t>
             </a:fld>
             <a:endParaRPr lang="de-DE"/>
           </a:p>
@@ -10324,13 +10340,13 @@
           <a:p>
             <a:pPr algn="l"/>
             <a:r>
-              <a:rPr lang="de-AT" sz="2400" b="1"/>
+              <a:rPr lang="de-AT" sz="2400" b="1" dirty="0"/>
               <a:t>Identifizierte Anforderungen</a:t>
             </a:r>
             <a:br>
-              <a:rPr lang="de-AT" sz="2400" b="1"/>
+              <a:rPr lang="de-AT" sz="2400" b="1" dirty="0"/>
             </a:br>
-            <a:endParaRPr lang="de-DE" sz="2400"/>
+            <a:endParaRPr lang="de-DE" sz="2400" dirty="0"/>
           </a:p>
         </p:txBody>
       </p:sp>
@@ -10895,10 +10911,10 @@
       </p:pic>
       <p:pic>
         <p:nvPicPr>
-          <p:cNvPr id="10" name="Inhaltsplatzhalter 9">
+          <p:cNvPr id="6" name="Inhaltsplatzhalter 5">
             <a:extLst>
               <a:ext uri="{FF2B5EF4-FFF2-40B4-BE49-F238E27FC236}">
-                <a16:creationId xmlns:a16="http://schemas.microsoft.com/office/drawing/2014/main" id="{54D028B5-EC39-868C-6057-0AA71BD4E96C}"/>
+                <a16:creationId xmlns:a16="http://schemas.microsoft.com/office/drawing/2014/main" id="{7073C52C-E4DA-A562-A5F0-BDDA1FC83806}"/>
               </a:ext>
             </a:extLst>
           </p:cNvPr>
@@ -10917,15 +10933,15 @@
               </a:ext>
             </a:extLst>
           </a:blip>
-          <a:srcRect b="7230"/>
+          <a:srcRect b="8228"/>
           <a:stretch>
             <a:fillRect/>
           </a:stretch>
         </p:blipFill>
         <p:spPr>
           <a:xfrm>
-            <a:off x="2485942" y="0"/>
-            <a:ext cx="9793561" cy="6886207"/>
+            <a:off x="2223432" y="-48601"/>
+            <a:ext cx="10079853" cy="6955200"/>
           </a:xfrm>
           <a:prstGeom prst="rect">
             <a:avLst/>
@@ -10984,12 +11000,12 @@
           <a:chExt cx="0" cy="0"/>
         </a:xfrm>
       </p:grpSpPr>
-      <p:sp>
-        <p:nvSpPr>
-          <p:cNvPr id="19" name="Rectangle 18">
+      <p:sp useBgFill="1">
+        <p:nvSpPr>
+          <p:cNvPr id="30" name="Rectangle 29">
             <a:extLst>
               <a:ext uri="{FF2B5EF4-FFF2-40B4-BE49-F238E27FC236}">
-                <a16:creationId xmlns:a16="http://schemas.microsoft.com/office/drawing/2014/main" id="{3A9C15D4-2EE7-4D05-B87C-91D1F3B9604B}"/>
+                <a16:creationId xmlns:a16="http://schemas.microsoft.com/office/drawing/2014/main" id="{922081EA-7107-46FA-A893-B15086A74875}"/>
               </a:ext>
               <a:ext uri="{C183D7F6-B498-43B3-948B-1728B52AA6E4}">
                 <adec:decorative xmlns:adec="http://schemas.microsoft.com/office/drawing/2017/decorative" val="1"/>
@@ -11009,15 +11025,12 @@
         </p:nvSpPr>
         <p:spPr>
           <a:xfrm>
-            <a:off x="4059935" y="0"/>
-            <a:ext cx="8132065" cy="6858000"/>
+            <a:off x="0" y="0"/>
+            <a:ext cx="12192000" cy="6858000"/>
           </a:xfrm>
           <a:prstGeom prst="rect">
             <a:avLst/>
           </a:prstGeom>
-          <a:solidFill>
-            <a:schemeClr val="bg1"/>
-          </a:solidFill>
           <a:ln>
             <a:noFill/>
           </a:ln>
@@ -11047,79 +11060,12 @@
           </a:p>
         </p:txBody>
       </p:sp>
-      <p:sp useBgFill="1">
-        <p:nvSpPr>
-          <p:cNvPr id="21" name="Rectangle 20">
+      <p:pic>
+        <p:nvPicPr>
+          <p:cNvPr id="32" name="Picture 31">
             <a:extLst>
               <a:ext uri="{FF2B5EF4-FFF2-40B4-BE49-F238E27FC236}">
-                <a16:creationId xmlns:a16="http://schemas.microsoft.com/office/drawing/2014/main" id="{4ED7B0FB-9654-4441-9545-02D458B68620}"/>
-              </a:ext>
-              <a:ext uri="{C183D7F6-B498-43B3-948B-1728B52AA6E4}">
-                <adec:decorative xmlns:adec="http://schemas.microsoft.com/office/drawing/2017/decorative" val="1"/>
-              </a:ext>
-            </a:extLst>
-          </p:cNvPr>
-          <p:cNvSpPr>
-            <a:spLocks noGrp="1" noRot="1" noChangeAspect="1" noMove="1" noResize="1" noEditPoints="1" noAdjustHandles="1" noChangeArrowheads="1" noChangeShapeType="1" noTextEdit="1"/>
-          </p:cNvSpPr>
-          <p:nvPr>
-            <p:extLst>
-              <p:ext uri="{386F3935-93C4-4BCD-93E2-E3B085C9AB24}">
-                <p16:designElem xmlns:p16="http://schemas.microsoft.com/office/powerpoint/2015/main" val="1"/>
-              </p:ext>
-            </p:extLst>
-          </p:nvPr>
-        </p:nvSpPr>
-        <p:spPr>
-          <a:xfrm>
-            <a:off x="0" y="0"/>
-            <a:ext cx="4059935" cy="6858000"/>
-          </a:xfrm>
-          <a:prstGeom prst="rect">
-            <a:avLst/>
-          </a:prstGeom>
-          <a:ln>
-            <a:noFill/>
-          </a:ln>
-          <a:effectLst>
-            <a:outerShdw blurRad="50800" dist="12700" algn="l" rotWithShape="0">
-              <a:prstClr val="black">
-                <a:alpha val="30000"/>
-              </a:prstClr>
-            </a:outerShdw>
-          </a:effectLst>
-        </p:spPr>
-        <p:style>
-          <a:lnRef idx="2">
-            <a:schemeClr val="accent1">
-              <a:shade val="50000"/>
-            </a:schemeClr>
-          </a:lnRef>
-          <a:fillRef idx="1">
-            <a:schemeClr val="accent1"/>
-          </a:fillRef>
-          <a:effectRef idx="0">
-            <a:schemeClr val="accent1"/>
-          </a:effectRef>
-          <a:fontRef idx="minor">
-            <a:schemeClr val="lt1"/>
-          </a:fontRef>
-        </p:style>
-        <p:txBody>
-          <a:bodyPr rtlCol="0" anchor="ctr"/>
-          <a:lstStyle/>
-          <a:p>
-            <a:pPr algn="ctr"/>
-            <a:endParaRPr lang="en-US"/>
-          </a:p>
-        </p:txBody>
-      </p:sp>
-      <p:pic>
-        <p:nvPicPr>
-          <p:cNvPr id="23" name="Picture 22">
-            <a:extLst>
-              <a:ext uri="{FF2B5EF4-FFF2-40B4-BE49-F238E27FC236}">
-                <a16:creationId xmlns:a16="http://schemas.microsoft.com/office/drawing/2014/main" id="{7BB94C57-FDF3-45A3-9D1F-904523D795D4}"/>
+                <a16:creationId xmlns:a16="http://schemas.microsoft.com/office/drawing/2014/main" id="{DD8889DF-D030-4BCD-9797-4BBD1986C26B}"/>
               </a:ext>
               <a:ext uri="{C183D7F6-B498-43B3-948B-1728B52AA6E4}">
                 <adec:decorative xmlns:adec="http://schemas.microsoft.com/office/drawing/2017/decorative" val="1"/>
@@ -11137,7 +11083,7 @@
             </p:extLst>
           </p:nvPr>
         </p:nvPicPr>
-        <p:blipFill rotWithShape="1">
+        <p:blipFill>
           <a:blip r:embed="rId2">
             <a:extLst>
               <a:ext uri="{28A0092B-C50C-407E-A947-70E740481C1C}">
@@ -11145,13 +11091,14 @@
               </a:ext>
             </a:extLst>
           </a:blip>
-          <a:srcRect r="66700" b="77917"/>
-          <a:stretch/>
+          <a:stretch>
+            <a:fillRect/>
+          </a:stretch>
         </p:blipFill>
         <p:spPr>
           <a:xfrm>
             <a:off x="0" y="0"/>
-            <a:ext cx="4059935" cy="1514475"/>
+            <a:ext cx="12192000" cy="6858000"/>
           </a:xfrm>
           <a:prstGeom prst="rect">
             <a:avLst/>
@@ -11176,31 +11123,45 @@
         </p:nvSpPr>
         <p:spPr>
           <a:xfrm>
-            <a:off x="641074" y="1419900"/>
-            <a:ext cx="2844002" cy="4018201"/>
+            <a:off x="8351757" y="2514600"/>
+            <a:ext cx="3420815" cy="1828800"/>
           </a:xfrm>
         </p:spPr>
         <p:txBody>
-          <a:bodyPr>
+          <a:bodyPr anchor="b">
             <a:normAutofit/>
           </a:bodyPr>
           <a:lstStyle/>
           <a:p>
             <a:pPr algn="l"/>
             <a:r>
-              <a:rPr lang="de-AT" sz="3400"/>
-              <a:t>Constraints &amp; Business Cases</a:t>
+              <a:rPr lang="de-AT" sz="4100" dirty="0">
+                <a:solidFill>
+                  <a:schemeClr val="tx1">
+                    <a:lumMod val="75000"/>
+                    <a:lumOff val="25000"/>
+                  </a:schemeClr>
+                </a:solidFill>
+              </a:rPr>
+              <a:t>Business Cases</a:t>
             </a:r>
-            <a:endParaRPr lang="de-DE" sz="3400"/>
-          </a:p>
-        </p:txBody>
-      </p:sp>
-      <p:sp>
-        <p:nvSpPr>
-          <p:cNvPr id="28" name="Rectangle 2">
+            <a:endParaRPr lang="de-DE" sz="4100" dirty="0">
+              <a:solidFill>
+                <a:schemeClr val="tx1">
+                  <a:lumMod val="75000"/>
+                  <a:lumOff val="25000"/>
+                </a:schemeClr>
+              </a:solidFill>
+            </a:endParaRPr>
+          </a:p>
+        </p:txBody>
+      </p:sp>
+      <p:sp>
+        <p:nvSpPr>
+          <p:cNvPr id="8" name="Rectangle 5">
             <a:extLst>
               <a:ext uri="{FF2B5EF4-FFF2-40B4-BE49-F238E27FC236}">
-                <a16:creationId xmlns:a16="http://schemas.microsoft.com/office/drawing/2014/main" id="{CDC42556-F433-EFA3-E002-09F52204E6CA}"/>
+                <a16:creationId xmlns:a16="http://schemas.microsoft.com/office/drawing/2014/main" id="{D1F879A3-BADB-5352-9CE8-9BBDEBCE67D8}"/>
               </a:ext>
             </a:extLst>
           </p:cNvPr>
@@ -11213,12 +11174,17 @@
         </p:nvSpPr>
         <p:spPr bwMode="auto">
           <a:xfrm>
-            <a:off x="4701008" y="1193576"/>
-            <a:ext cx="6576591" cy="4470850"/>
+            <a:off x="279400" y="2264258"/>
+            <a:ext cx="7652929" cy="2710486"/>
           </a:xfrm>
           <a:prstGeom prst="rect">
             <a:avLst/>
           </a:prstGeom>
+          <a:noFill/>
+          <a:ln>
+            <a:noFill/>
+          </a:ln>
+          <a:effectLst/>
           <a:extLst>
             <a:ext uri="{909E8E84-426E-40DD-AFC4-6F175D3DCCD1}">
               <a14:hiddenFill xmlns:a14="http://schemas.microsoft.com/office/drawing/2010/main">
@@ -11249,23 +11215,23 @@
           </a:extLst>
         </p:spPr>
         <p:txBody>
-          <a:bodyPr vert="horz" lIns="91440" tIns="45720" rIns="91440" bIns="45720" numCol="1" anchor="ctr" anchorCtr="0" compatLnSpc="1">
+          <a:bodyPr vert="horz" wrap="none" lIns="91440" tIns="45720" rIns="91440" bIns="45720" numCol="1" anchor="ctr" anchorCtr="0" compatLnSpc="1">
             <a:prstTxWarp prst="textNoShape">
               <a:avLst/>
             </a:prstTxWarp>
-            <a:normAutofit/>
+            <a:spAutoFit/>
           </a:bodyPr>
           <a:lstStyle/>
           <a:p>
-            <a:pPr marL="0" marR="0" lvl="0" indent="0" defTabSz="914400" rtl="0" eaLnBrk="0" fontAlgn="base" latinLnBrk="0" hangingPunct="0">
+            <a:pPr marL="0" marR="0" lvl="0" indent="0" algn="l" defTabSz="914400" rtl="0" eaLnBrk="0" fontAlgn="base" latinLnBrk="0" hangingPunct="0">
               <a:lnSpc>
-                <a:spcPct val="110000"/>
+                <a:spcPct val="250000"/>
               </a:lnSpc>
               <a:spcBef>
                 <a:spcPct val="0"/>
               </a:spcBef>
               <a:spcAft>
-                <a:spcPts val="600"/>
+                <a:spcPct val="0"/>
               </a:spcAft>
               <a:buClrTx/>
               <a:buSzTx/>
@@ -11274,33 +11240,29 @@
               <a:tabLst/>
             </a:pPr>
             <a:r>
-              <a:rPr kumimoji="0" lang="de-DE" altLang="de-DE" sz="1400" b="1" i="0" u="none" strike="noStrike" cap="none" normalizeH="0" baseline="0">
+              <a:rPr kumimoji="0" lang="de-DE" altLang="de-DE" sz="2400" b="0" i="0" u="none" strike="noStrike" cap="none" normalizeH="0" baseline="0" dirty="0">
                 <a:ln>
                   <a:noFill/>
                 </a:ln>
+                <a:solidFill>
+                  <a:schemeClr val="tx1"/>
+                </a:solidFill>
                 <a:effectLst/>
-                <a:latin typeface="Arial" panose="020B0604020202020204" pitchFamily="34" charset="0"/>
+                <a:latin typeface="+mj-lt"/>
               </a:rPr>
-              <a:t>UC 1: Kassensystem (Point of Sale)</a:t>
+              <a:t>UC 1: Bestellung &amp; Wareneingang (Ablauf, Logik, Abschluss)</a:t>
             </a:r>
-            <a:endParaRPr kumimoji="0" lang="de-DE" altLang="de-DE" sz="1400" b="0" i="0" u="none" strike="noStrike" cap="none" normalizeH="0" baseline="0">
-              <a:ln>
-                <a:noFill/>
-              </a:ln>
-              <a:effectLst/>
-              <a:latin typeface="Arial" panose="020B0604020202020204" pitchFamily="34" charset="0"/>
-            </a:endParaRPr>
-          </a:p>
-          <a:p>
-            <a:pPr marL="0" marR="0" lvl="0" indent="0" defTabSz="914400" rtl="0" eaLnBrk="0" fontAlgn="base" latinLnBrk="0" hangingPunct="0">
+          </a:p>
+          <a:p>
+            <a:pPr marL="0" marR="0" lvl="0" indent="0" algn="l" defTabSz="914400" rtl="0" eaLnBrk="0" fontAlgn="base" latinLnBrk="0" hangingPunct="0">
               <a:lnSpc>
-                <a:spcPct val="110000"/>
+                <a:spcPct val="250000"/>
               </a:lnSpc>
               <a:spcBef>
                 <a:spcPct val="0"/>
               </a:spcBef>
               <a:spcAft>
-                <a:spcPts val="600"/>
+                <a:spcPct val="0"/>
               </a:spcAft>
               <a:buClrTx/>
               <a:buSzTx/>
@@ -11309,36 +11271,55 @@
               <a:tabLst/>
             </a:pPr>
             <a:r>
-              <a:rPr kumimoji="0" lang="de-DE" altLang="de-DE" sz="1400" b="0" i="1" u="none" strike="noStrike" cap="none" normalizeH="0" baseline="0">
+              <a:rPr kumimoji="0" lang="de-DE" altLang="de-DE" sz="2400" b="0" i="0" u="none" strike="noStrike" cap="none" normalizeH="0" baseline="0" dirty="0">
                 <a:ln>
                   <a:noFill/>
                 </a:ln>
+                <a:solidFill>
+                  <a:schemeClr val="tx1"/>
+                </a:solidFill>
                 <a:effectLst/>
-                <a:latin typeface="Arial" panose="020B0604020202020204" pitchFamily="34" charset="0"/>
+                <a:latin typeface="+mj-lt"/>
               </a:rPr>
-              <a:t>Erfassung:</a:t>
+              <a:t>UC 2: Kundenkauf am Point </a:t>
             </a:r>
             <a:r>
-              <a:rPr kumimoji="0" lang="de-DE" altLang="de-DE" sz="1400" b="0" i="0" u="none" strike="noStrike" cap="none" normalizeH="0" baseline="0">
+              <a:rPr kumimoji="0" lang="de-DE" altLang="de-DE" sz="2400" b="0" i="0" u="none" strike="noStrike" cap="none" normalizeH="0" baseline="0" dirty="0" err="1">
                 <a:ln>
                   <a:noFill/>
                 </a:ln>
+                <a:solidFill>
+                  <a:schemeClr val="tx1"/>
+                </a:solidFill>
                 <a:effectLst/>
-                <a:latin typeface="Arial" panose="020B0604020202020204" pitchFamily="34" charset="0"/>
+                <a:latin typeface="+mj-lt"/>
               </a:rPr>
-              <a:t> Kassenbon buchen, Lagerbestand automatisch senken.</a:t>
+              <a:t>of</a:t>
             </a:r>
-          </a:p>
-          <a:p>
-            <a:pPr marL="0" marR="0" lvl="0" indent="0" defTabSz="914400" rtl="0" eaLnBrk="0" fontAlgn="base" latinLnBrk="0" hangingPunct="0">
+            <a:r>
+              <a:rPr kumimoji="0" lang="de-DE" altLang="de-DE" sz="2400" b="0" i="0" u="none" strike="noStrike" cap="none" normalizeH="0" baseline="0" dirty="0">
+                <a:ln>
+                  <a:noFill/>
+                </a:ln>
+                <a:solidFill>
+                  <a:schemeClr val="tx1"/>
+                </a:solidFill>
+                <a:effectLst/>
+                <a:latin typeface="+mj-lt"/>
+              </a:rPr>
+              <a:t> Sale (POS)</a:t>
+            </a:r>
+          </a:p>
+          <a:p>
+            <a:pPr marL="0" marR="0" lvl="0" indent="0" algn="l" defTabSz="914400" rtl="0" eaLnBrk="0" fontAlgn="base" latinLnBrk="0" hangingPunct="0">
               <a:lnSpc>
-                <a:spcPct val="110000"/>
+                <a:spcPct val="250000"/>
               </a:lnSpc>
               <a:spcBef>
                 <a:spcPct val="0"/>
               </a:spcBef>
               <a:spcAft>
-                <a:spcPts val="600"/>
+                <a:spcPct val="0"/>
               </a:spcAft>
               <a:buClrTx/>
               <a:buSzTx/>
@@ -11347,407 +11328,21 @@
               <a:tabLst/>
             </a:pPr>
             <a:r>
-              <a:rPr kumimoji="0" lang="de-DE" altLang="de-DE" sz="1400" b="0" i="1" u="none" strike="noStrike" cap="none" normalizeH="0" baseline="0">
+              <a:rPr kumimoji="0" lang="de-DE" altLang="de-DE" sz="2400" b="0" i="0" u="none" strike="noStrike" cap="none" normalizeH="0" baseline="0" dirty="0">
                 <a:ln>
                   <a:noFill/>
                 </a:ln>
+                <a:solidFill>
+                  <a:schemeClr val="tx1"/>
+                </a:solidFill>
                 <a:effectLst/>
-                <a:latin typeface="Arial" panose="020B0604020202020204" pitchFamily="34" charset="0"/>
+                <a:latin typeface="+mj-lt"/>
               </a:rPr>
-              <a:t>Problemfall:</a:t>
+              <a:t>UC 3: Aktuelle Bestandsanzeige (Inventar-Übersicht)</a:t>
             </a:r>
-            <a:r>
-              <a:rPr kumimoji="0" lang="de-DE" altLang="de-DE" sz="1400" b="0" i="0" u="none" strike="noStrike" cap="none" normalizeH="0" baseline="0">
-                <a:ln>
-                  <a:noFill/>
-                </a:ln>
-                <a:effectLst/>
-                <a:latin typeface="Arial" panose="020B0604020202020204" pitchFamily="34" charset="0"/>
-              </a:rPr>
-              <a:t> Automatischer Abbruch durch Trigger bei Altersunterschreitung (Tabak/Lotto).</a:t>
-            </a:r>
-          </a:p>
-          <a:p>
-            <a:pPr marL="0" marR="0" lvl="0" indent="0" defTabSz="914400" rtl="0" eaLnBrk="0" fontAlgn="base" latinLnBrk="0" hangingPunct="0">
-              <a:lnSpc>
-                <a:spcPct val="110000"/>
-              </a:lnSpc>
-              <a:spcBef>
-                <a:spcPct val="0"/>
-              </a:spcBef>
-              <a:spcAft>
-                <a:spcPts val="600"/>
-              </a:spcAft>
-              <a:buClrTx/>
-              <a:buSzTx/>
-              <a:buFontTx/>
-              <a:buChar char="•"/>
-              <a:tabLst/>
-            </a:pPr>
-            <a:r>
-              <a:rPr kumimoji="0" lang="de-DE" altLang="de-DE" sz="1400" b="0" i="1" u="none" strike="noStrike" cap="none" normalizeH="0" baseline="0">
-                <a:ln>
-                  <a:noFill/>
-                </a:ln>
-                <a:effectLst/>
-                <a:latin typeface="Arial" panose="020B0604020202020204" pitchFamily="34" charset="0"/>
-              </a:rPr>
-              <a:t>Info-Gewinnung:</a:t>
-            </a:r>
-            <a:r>
-              <a:rPr kumimoji="0" lang="de-DE" altLang="de-DE" sz="1400" b="0" i="0" u="none" strike="noStrike" cap="none" normalizeH="0" baseline="0">
-                <a:ln>
-                  <a:noFill/>
-                </a:ln>
-                <a:effectLst/>
-                <a:latin typeface="Arial" panose="020B0604020202020204" pitchFamily="34" charset="0"/>
-              </a:rPr>
-              <a:t> Tagesumsatz-Auswertung pro Kategorie.</a:t>
-            </a:r>
-          </a:p>
-          <a:p>
-            <a:pPr marL="0" marR="0" lvl="0" indent="0" defTabSz="914400" rtl="0" eaLnBrk="0" fontAlgn="base" latinLnBrk="0" hangingPunct="0">
-              <a:lnSpc>
-                <a:spcPct val="110000"/>
-              </a:lnSpc>
-              <a:spcBef>
-                <a:spcPct val="0"/>
-              </a:spcBef>
-              <a:spcAft>
-                <a:spcPts val="600"/>
-              </a:spcAft>
-              <a:buClrTx/>
-              <a:buSzTx/>
-              <a:buFontTx/>
-              <a:buChar char="•"/>
-              <a:tabLst/>
-            </a:pPr>
-            <a:endParaRPr kumimoji="0" lang="de-DE" altLang="de-DE" sz="1400" b="0" i="0" u="none" strike="noStrike" cap="none" normalizeH="0" baseline="0">
-              <a:ln>
-                <a:noFill/>
-              </a:ln>
-              <a:effectLst/>
-              <a:latin typeface="Arial" panose="020B0604020202020204" pitchFamily="34" charset="0"/>
-            </a:endParaRPr>
-          </a:p>
-          <a:p>
-            <a:pPr marL="0" marR="0" lvl="0" indent="0" defTabSz="914400" rtl="0" eaLnBrk="0" fontAlgn="base" latinLnBrk="0" hangingPunct="0">
-              <a:lnSpc>
-                <a:spcPct val="110000"/>
-              </a:lnSpc>
-              <a:spcBef>
-                <a:spcPct val="0"/>
-              </a:spcBef>
-              <a:spcAft>
-                <a:spcPts val="600"/>
-              </a:spcAft>
-              <a:buClrTx/>
-              <a:buSzTx/>
-              <a:buFontTx/>
-              <a:buChar char="•"/>
-              <a:tabLst/>
-            </a:pPr>
-            <a:r>
-              <a:rPr kumimoji="0" lang="de-DE" altLang="de-DE" sz="1400" b="1" i="0" u="none" strike="noStrike" cap="none" normalizeH="0" baseline="0">
-                <a:ln>
-                  <a:noFill/>
-                </a:ln>
-                <a:effectLst/>
-                <a:latin typeface="Arial" panose="020B0604020202020204" pitchFamily="34" charset="0"/>
-              </a:rPr>
-              <a:t>UC 2: Zeitschriften-Abos für Stammkunden</a:t>
-            </a:r>
-            <a:endParaRPr kumimoji="0" lang="de-DE" altLang="de-DE" sz="1400" b="0" i="0" u="none" strike="noStrike" cap="none" normalizeH="0" baseline="0">
-              <a:ln>
-                <a:noFill/>
-              </a:ln>
-              <a:effectLst/>
-              <a:latin typeface="Arial" panose="020B0604020202020204" pitchFamily="34" charset="0"/>
-            </a:endParaRPr>
-          </a:p>
-          <a:p>
-            <a:pPr marL="0" marR="0" lvl="0" indent="0" defTabSz="914400" rtl="0" eaLnBrk="0" fontAlgn="base" latinLnBrk="0" hangingPunct="0">
-              <a:lnSpc>
-                <a:spcPct val="110000"/>
-              </a:lnSpc>
-              <a:spcBef>
-                <a:spcPct val="0"/>
-              </a:spcBef>
-              <a:spcAft>
-                <a:spcPts val="600"/>
-              </a:spcAft>
-              <a:buClrTx/>
-              <a:buSzTx/>
-              <a:buFontTx/>
-              <a:buChar char="•"/>
-              <a:tabLst/>
-            </a:pPr>
-            <a:r>
-              <a:rPr kumimoji="0" lang="de-DE" altLang="de-DE" sz="1400" b="0" i="1" u="none" strike="noStrike" cap="none" normalizeH="0" baseline="0">
-                <a:ln>
-                  <a:noFill/>
-                </a:ln>
-                <a:effectLst/>
-                <a:latin typeface="Arial" panose="020B0604020202020204" pitchFamily="34" charset="0"/>
-              </a:rPr>
-              <a:t>Erfassung:</a:t>
-            </a:r>
-            <a:r>
-              <a:rPr kumimoji="0" lang="de-DE" altLang="de-DE" sz="1400" b="0" i="0" u="none" strike="noStrike" cap="none" normalizeH="0" baseline="0">
-                <a:ln>
-                  <a:noFill/>
-                </a:ln>
-                <a:effectLst/>
-                <a:latin typeface="Arial" panose="020B0604020202020204" pitchFamily="34" charset="0"/>
-              </a:rPr>
-              <a:t> Kunde, Magazin und Abhol-Wochentag verknüpfen.</a:t>
-            </a:r>
-          </a:p>
-          <a:p>
-            <a:pPr marL="0" marR="0" lvl="0" indent="0" defTabSz="914400" rtl="0" eaLnBrk="0" fontAlgn="base" latinLnBrk="0" hangingPunct="0">
-              <a:lnSpc>
-                <a:spcPct val="110000"/>
-              </a:lnSpc>
-              <a:spcBef>
-                <a:spcPct val="0"/>
-              </a:spcBef>
-              <a:spcAft>
-                <a:spcPts val="600"/>
-              </a:spcAft>
-              <a:buClrTx/>
-              <a:buSzTx/>
-              <a:buFontTx/>
-              <a:buChar char="•"/>
-              <a:tabLst/>
-            </a:pPr>
-            <a:r>
-              <a:rPr kumimoji="0" lang="de-DE" altLang="de-DE" sz="1400" b="0" i="1" u="none" strike="noStrike" cap="none" normalizeH="0" baseline="0">
-                <a:ln>
-                  <a:noFill/>
-                </a:ln>
-                <a:effectLst/>
-                <a:latin typeface="Arial" panose="020B0604020202020204" pitchFamily="34" charset="0"/>
-              </a:rPr>
-              <a:t>Info-Gewinnung:</a:t>
-            </a:r>
-            <a:r>
-              <a:rPr kumimoji="0" lang="de-DE" altLang="de-DE" sz="1400" b="0" i="0" u="none" strike="noStrike" cap="none" normalizeH="0" baseline="0">
-                <a:ln>
-                  <a:noFill/>
-                </a:ln>
-                <a:effectLst/>
-                <a:latin typeface="Arial" panose="020B0604020202020204" pitchFamily="34" charset="0"/>
-              </a:rPr>
-              <a:t> Tägliche "Pick-Liste" (Wer holt heute was ab?).</a:t>
-            </a:r>
-          </a:p>
-          <a:p>
-            <a:pPr marL="0" marR="0" lvl="0" indent="0" defTabSz="914400" rtl="0" eaLnBrk="0" fontAlgn="base" latinLnBrk="0" hangingPunct="0">
-              <a:lnSpc>
-                <a:spcPct val="110000"/>
-              </a:lnSpc>
-              <a:spcBef>
-                <a:spcPct val="0"/>
-              </a:spcBef>
-              <a:spcAft>
-                <a:spcPts val="600"/>
-              </a:spcAft>
-              <a:buClrTx/>
-              <a:buSzTx/>
-              <a:buFontTx/>
-              <a:buChar char="•"/>
-              <a:tabLst/>
-            </a:pPr>
-            <a:endParaRPr kumimoji="0" lang="de-DE" altLang="de-DE" sz="1400" b="0" i="0" u="none" strike="noStrike" cap="none" normalizeH="0" baseline="0">
-              <a:ln>
-                <a:noFill/>
-              </a:ln>
-              <a:effectLst/>
-              <a:latin typeface="Arial" panose="020B0604020202020204" pitchFamily="34" charset="0"/>
-            </a:endParaRPr>
-          </a:p>
-          <a:p>
-            <a:pPr marL="0" marR="0" lvl="0" indent="0" defTabSz="914400" rtl="0" eaLnBrk="0" fontAlgn="base" latinLnBrk="0" hangingPunct="0">
-              <a:lnSpc>
-                <a:spcPct val="110000"/>
-              </a:lnSpc>
-              <a:spcBef>
-                <a:spcPct val="0"/>
-              </a:spcBef>
-              <a:spcAft>
-                <a:spcPts val="600"/>
-              </a:spcAft>
-              <a:buClrTx/>
-              <a:buSzTx/>
-              <a:buFontTx/>
-              <a:buChar char="•"/>
-              <a:tabLst/>
-            </a:pPr>
-            <a:r>
-              <a:rPr kumimoji="0" lang="de-DE" altLang="de-DE" sz="1400" b="1" i="0" u="none" strike="noStrike" cap="none" normalizeH="0" baseline="0">
-                <a:ln>
-                  <a:noFill/>
-                </a:ln>
-                <a:effectLst/>
-                <a:latin typeface="Arial" panose="020B0604020202020204" pitchFamily="34" charset="0"/>
-              </a:rPr>
-              <a:t>UC 3: Bestellwesen &amp; Wareneingang</a:t>
-            </a:r>
-            <a:endParaRPr kumimoji="0" lang="de-DE" altLang="de-DE" sz="1400" b="0" i="0" u="none" strike="noStrike" cap="none" normalizeH="0" baseline="0">
-              <a:ln>
-                <a:noFill/>
-              </a:ln>
-              <a:effectLst/>
-              <a:latin typeface="Arial" panose="020B0604020202020204" pitchFamily="34" charset="0"/>
-            </a:endParaRPr>
-          </a:p>
-          <a:p>
-            <a:pPr marL="0" marR="0" lvl="0" indent="0" defTabSz="914400" rtl="0" eaLnBrk="0" fontAlgn="base" latinLnBrk="0" hangingPunct="0">
-              <a:lnSpc>
-                <a:spcPct val="110000"/>
-              </a:lnSpc>
-              <a:spcBef>
-                <a:spcPct val="0"/>
-              </a:spcBef>
-              <a:spcAft>
-                <a:spcPts val="600"/>
-              </a:spcAft>
-              <a:buClrTx/>
-              <a:buSzTx/>
-              <a:buFontTx/>
-              <a:buChar char="•"/>
-              <a:tabLst/>
-            </a:pPr>
-            <a:r>
-              <a:rPr kumimoji="0" lang="de-DE" altLang="de-DE" sz="1400" b="0" i="1" u="none" strike="noStrike" cap="none" normalizeH="0" baseline="0">
-                <a:ln>
-                  <a:noFill/>
-                </a:ln>
-                <a:effectLst/>
-                <a:latin typeface="Arial" panose="020B0604020202020204" pitchFamily="34" charset="0"/>
-              </a:rPr>
-              <a:t>Erfassung:</a:t>
-            </a:r>
-            <a:r>
-              <a:rPr kumimoji="0" lang="de-DE" altLang="de-DE" sz="1400" b="0" i="0" u="none" strike="noStrike" cap="none" normalizeH="0" baseline="0">
-                <a:ln>
-                  <a:noFill/>
-                </a:ln>
-                <a:effectLst/>
-                <a:latin typeface="Arial" panose="020B0604020202020204" pitchFamily="34" charset="0"/>
-              </a:rPr>
-              <a:t> Lieferung verbuchen (Soll/Ist-Abgleich der Menge).</a:t>
-            </a:r>
-          </a:p>
-          <a:p>
-            <a:pPr marL="0" marR="0" lvl="0" indent="0" defTabSz="914400" rtl="0" eaLnBrk="0" fontAlgn="base" latinLnBrk="0" hangingPunct="0">
-              <a:lnSpc>
-                <a:spcPct val="110000"/>
-              </a:lnSpc>
-              <a:spcBef>
-                <a:spcPct val="0"/>
-              </a:spcBef>
-              <a:spcAft>
-                <a:spcPts val="600"/>
-              </a:spcAft>
-              <a:buClrTx/>
-              <a:buSzTx/>
-              <a:buFontTx/>
-              <a:buChar char="•"/>
-              <a:tabLst/>
-            </a:pPr>
-            <a:r>
-              <a:rPr kumimoji="0" lang="de-DE" altLang="de-DE" sz="1400" b="0" i="1" u="none" strike="noStrike" cap="none" normalizeH="0" baseline="0">
-                <a:ln>
-                  <a:noFill/>
-                </a:ln>
-                <a:effectLst/>
-                <a:latin typeface="Arial" panose="020B0604020202020204" pitchFamily="34" charset="0"/>
-              </a:rPr>
-              <a:t>Info-Gewinnung:</a:t>
-            </a:r>
-            <a:r>
-              <a:rPr kumimoji="0" lang="de-DE" altLang="de-DE" sz="1400" b="0" i="0" u="none" strike="noStrike" cap="none" normalizeH="0" baseline="0">
-                <a:ln>
-                  <a:noFill/>
-                </a:ln>
-                <a:effectLst/>
-                <a:latin typeface="Arial" panose="020B0604020202020204" pitchFamily="34" charset="0"/>
-              </a:rPr>
-              <a:t> Warn-Liste bei kritischem Lagerbestand für Nachbestellungen.</a:t>
-            </a:r>
-          </a:p>
-          <a:p>
-            <a:pPr marL="0" marR="0" lvl="0" indent="0" defTabSz="914400" rtl="0" eaLnBrk="0" fontAlgn="base" latinLnBrk="0" hangingPunct="0">
-              <a:lnSpc>
-                <a:spcPct val="110000"/>
-              </a:lnSpc>
-              <a:spcBef>
-                <a:spcPct val="0"/>
-              </a:spcBef>
-              <a:spcAft>
-                <a:spcPts val="600"/>
-              </a:spcAft>
-              <a:buClrTx/>
-              <a:buSzTx/>
-              <a:buFontTx/>
-              <a:buNone/>
-              <a:tabLst/>
-            </a:pPr>
-            <a:endParaRPr kumimoji="0" lang="de-DE" altLang="de-DE" sz="1400" b="0" i="0" u="none" strike="noStrike" cap="none" normalizeH="0" baseline="0">
-              <a:ln>
-                <a:noFill/>
-              </a:ln>
-              <a:effectLst/>
-              <a:latin typeface="Arial" panose="020B0604020202020204" pitchFamily="34" charset="0"/>
-            </a:endParaRPr>
-          </a:p>
-        </p:txBody>
-      </p:sp>
-      <p:pic>
-        <p:nvPicPr>
-          <p:cNvPr id="25" name="Picture 24">
-            <a:extLst>
-              <a:ext uri="{FF2B5EF4-FFF2-40B4-BE49-F238E27FC236}">
-                <a16:creationId xmlns:a16="http://schemas.microsoft.com/office/drawing/2014/main" id="{6AEBDF1A-221A-4497-BBA9-57A70D161510}"/>
-              </a:ext>
-              <a:ext uri="{C183D7F6-B498-43B3-948B-1728B52AA6E4}">
-                <adec:decorative xmlns:adec="http://schemas.microsoft.com/office/drawing/2017/decorative" val="1"/>
-              </a:ext>
-            </a:extLst>
-          </p:cNvPr>
-          <p:cNvPicPr>
-            <a:picLocks noGrp="1" noRot="1" noChangeAspect="1" noMove="1" noResize="1" noEditPoints="1" noAdjustHandles="1" noChangeArrowheads="1" noChangeShapeType="1" noCrop="1"/>
-          </p:cNvPicPr>
-          <p:nvPr>
-            <p:extLst>
-              <p:ext uri="{386F3935-93C4-4BCD-93E2-E3B085C9AB24}">
-                <p16:designElem xmlns:p16="http://schemas.microsoft.com/office/powerpoint/2015/main" val="1"/>
-              </p:ext>
-            </p:extLst>
-          </p:nvPr>
-        </p:nvPicPr>
-        <p:blipFill rotWithShape="1">
-          <a:blip r:embed="rId3">
-            <a:extLst>
-              <a:ext uri="{28A0092B-C50C-407E-A947-70E740481C1C}">
-                <a14:useLocalDpi xmlns:a14="http://schemas.microsoft.com/office/drawing/2010/main" val="0"/>
-              </a:ext>
-            </a:extLst>
-          </a:blip>
-          <a:srcRect l="78750" t="72830" b="14149"/>
-          <a:stretch/>
-        </p:blipFill>
-        <p:spPr>
-          <a:xfrm>
-            <a:off x="1377059" y="5962903"/>
-            <a:ext cx="2590800" cy="892925"/>
-          </a:xfrm>
-          <a:prstGeom prst="rect">
-            <a:avLst/>
-          </a:prstGeom>
-        </p:spPr>
-      </p:pic>
+          </a:p>
+        </p:txBody>
+      </p:sp>
     </p:spTree>
     <p:extLst>
       <p:ext uri="{BB962C8B-B14F-4D97-AF65-F5344CB8AC3E}">

</xml_diff>

<commit_message>
Neues ERD in besserer Groeße
</commit_message>
<xml_diff>
--- a/docs/Präsentation1803.pptx
+++ b/docs/Präsentation1803.pptx
@@ -4,6 +4,9 @@
   <p:sldMasterIdLst>
     <p:sldMasterId id="2147483709" r:id="rId1"/>
   </p:sldMasterIdLst>
+  <p:notesMasterIdLst>
+    <p:notesMasterId r:id="rId6"/>
+  </p:notesMasterIdLst>
   <p:sldIdLst>
     <p:sldId id="256" r:id="rId2"/>
     <p:sldId id="257" r:id="rId3"/>
@@ -3444,6 +3447,440 @@
 </dgm:styleDef>
 </file>
 
+<file path=ppt/notesMasters/notesMaster1.xml><?xml version="1.0" encoding="utf-8"?>
+<p:notesMaster xmlns:a="http://schemas.openxmlformats.org/drawingml/2006/main" xmlns:r="http://schemas.openxmlformats.org/officeDocument/2006/relationships" xmlns:p="http://schemas.openxmlformats.org/presentationml/2006/main">
+  <p:cSld>
+    <p:bg>
+      <p:bgRef idx="1001">
+        <a:schemeClr val="bg1"/>
+      </p:bgRef>
+    </p:bg>
+    <p:spTree>
+      <p:nvGrpSpPr>
+        <p:cNvPr id="1" name=""/>
+        <p:cNvGrpSpPr/>
+        <p:nvPr/>
+      </p:nvGrpSpPr>
+      <p:grpSpPr>
+        <a:xfrm>
+          <a:off x="0" y="0"/>
+          <a:ext cx="0" cy="0"/>
+          <a:chOff x="0" y="0"/>
+          <a:chExt cx="0" cy="0"/>
+        </a:xfrm>
+      </p:grpSpPr>
+      <p:sp>
+        <p:nvSpPr>
+          <p:cNvPr id="2" name="Kopfzeilenplatzhalter 1"/>
+          <p:cNvSpPr>
+            <a:spLocks noGrp="1"/>
+          </p:cNvSpPr>
+          <p:nvPr>
+            <p:ph type="hdr" sz="quarter"/>
+          </p:nvPr>
+        </p:nvSpPr>
+        <p:spPr>
+          <a:xfrm>
+            <a:off x="0" y="0"/>
+            <a:ext cx="2971800" cy="458788"/>
+          </a:xfrm>
+          <a:prstGeom prst="rect">
+            <a:avLst/>
+          </a:prstGeom>
+        </p:spPr>
+        <p:txBody>
+          <a:bodyPr vert="horz" lIns="91440" tIns="45720" rIns="91440" bIns="45720" rtlCol="0"/>
+          <a:lstStyle>
+            <a:lvl1pPr algn="l">
+              <a:defRPr sz="1200"/>
+            </a:lvl1pPr>
+          </a:lstStyle>
+          <a:p>
+            <a:endParaRPr lang="de-AT"/>
+          </a:p>
+        </p:txBody>
+      </p:sp>
+      <p:sp>
+        <p:nvSpPr>
+          <p:cNvPr id="3" name="Datumsplatzhalter 2"/>
+          <p:cNvSpPr>
+            <a:spLocks noGrp="1"/>
+          </p:cNvSpPr>
+          <p:nvPr>
+            <p:ph type="dt" idx="1"/>
+          </p:nvPr>
+        </p:nvSpPr>
+        <p:spPr>
+          <a:xfrm>
+            <a:off x="3884613" y="0"/>
+            <a:ext cx="2971800" cy="458788"/>
+          </a:xfrm>
+          <a:prstGeom prst="rect">
+            <a:avLst/>
+          </a:prstGeom>
+        </p:spPr>
+        <p:txBody>
+          <a:bodyPr vert="horz" lIns="91440" tIns="45720" rIns="91440" bIns="45720" rtlCol="0"/>
+          <a:lstStyle>
+            <a:lvl1pPr algn="r">
+              <a:defRPr sz="1200"/>
+            </a:lvl1pPr>
+          </a:lstStyle>
+          <a:p>
+            <a:fld id="{F8E09CD7-2AF6-47BA-ABD4-4724CD9E78CE}" type="datetimeFigureOut">
+              <a:rPr lang="de-AT" smtClean="0"/>
+              <a:t>25.03.2026</a:t>
+            </a:fld>
+            <a:endParaRPr lang="de-AT"/>
+          </a:p>
+        </p:txBody>
+      </p:sp>
+      <p:sp>
+        <p:nvSpPr>
+          <p:cNvPr id="4" name="Folienbildplatzhalter 3"/>
+          <p:cNvSpPr>
+            <a:spLocks noGrp="1" noRot="1" noChangeAspect="1"/>
+          </p:cNvSpPr>
+          <p:nvPr>
+            <p:ph type="sldImg" idx="2"/>
+          </p:nvPr>
+        </p:nvSpPr>
+        <p:spPr>
+          <a:xfrm>
+            <a:off x="685800" y="1143000"/>
+            <a:ext cx="5486400" cy="3086100"/>
+          </a:xfrm>
+          <a:prstGeom prst="rect">
+            <a:avLst/>
+          </a:prstGeom>
+          <a:noFill/>
+          <a:ln w="12700">
+            <a:solidFill>
+              <a:prstClr val="black"/>
+            </a:solidFill>
+          </a:ln>
+        </p:spPr>
+        <p:txBody>
+          <a:bodyPr vert="horz" lIns="91440" tIns="45720" rIns="91440" bIns="45720" rtlCol="0" anchor="ctr"/>
+          <a:lstStyle/>
+          <a:p>
+            <a:endParaRPr lang="de-AT"/>
+          </a:p>
+        </p:txBody>
+      </p:sp>
+      <p:sp>
+        <p:nvSpPr>
+          <p:cNvPr id="5" name="Notizenplatzhalter 4"/>
+          <p:cNvSpPr>
+            <a:spLocks noGrp="1"/>
+          </p:cNvSpPr>
+          <p:nvPr>
+            <p:ph type="body" sz="quarter" idx="3"/>
+          </p:nvPr>
+        </p:nvSpPr>
+        <p:spPr>
+          <a:xfrm>
+            <a:off x="685800" y="4400550"/>
+            <a:ext cx="5486400" cy="3600450"/>
+          </a:xfrm>
+          <a:prstGeom prst="rect">
+            <a:avLst/>
+          </a:prstGeom>
+        </p:spPr>
+        <p:txBody>
+          <a:bodyPr vert="horz" lIns="91440" tIns="45720" rIns="91440" bIns="45720" rtlCol="0"/>
+          <a:lstStyle/>
+          <a:p>
+            <a:pPr lvl="0"/>
+            <a:r>
+              <a:rPr lang="de-DE"/>
+              <a:t>Mastertextformat bearbeiten</a:t>
+            </a:r>
+          </a:p>
+          <a:p>
+            <a:pPr lvl="1"/>
+            <a:r>
+              <a:rPr lang="de-DE"/>
+              <a:t>Zweite Ebene</a:t>
+            </a:r>
+          </a:p>
+          <a:p>
+            <a:pPr lvl="2"/>
+            <a:r>
+              <a:rPr lang="de-DE"/>
+              <a:t>Dritte Ebene</a:t>
+            </a:r>
+          </a:p>
+          <a:p>
+            <a:pPr lvl="3"/>
+            <a:r>
+              <a:rPr lang="de-DE"/>
+              <a:t>Vierte Ebene</a:t>
+            </a:r>
+          </a:p>
+          <a:p>
+            <a:pPr lvl="4"/>
+            <a:r>
+              <a:rPr lang="de-DE"/>
+              <a:t>Fünfte Ebene</a:t>
+            </a:r>
+            <a:endParaRPr lang="de-AT"/>
+          </a:p>
+        </p:txBody>
+      </p:sp>
+      <p:sp>
+        <p:nvSpPr>
+          <p:cNvPr id="6" name="Fußzeilenplatzhalter 5"/>
+          <p:cNvSpPr>
+            <a:spLocks noGrp="1"/>
+          </p:cNvSpPr>
+          <p:nvPr>
+            <p:ph type="ftr" sz="quarter" idx="4"/>
+          </p:nvPr>
+        </p:nvSpPr>
+        <p:spPr>
+          <a:xfrm>
+            <a:off x="0" y="8685213"/>
+            <a:ext cx="2971800" cy="458787"/>
+          </a:xfrm>
+          <a:prstGeom prst="rect">
+            <a:avLst/>
+          </a:prstGeom>
+        </p:spPr>
+        <p:txBody>
+          <a:bodyPr vert="horz" lIns="91440" tIns="45720" rIns="91440" bIns="45720" rtlCol="0" anchor="b"/>
+          <a:lstStyle>
+            <a:lvl1pPr algn="l">
+              <a:defRPr sz="1200"/>
+            </a:lvl1pPr>
+          </a:lstStyle>
+          <a:p>
+            <a:endParaRPr lang="de-AT"/>
+          </a:p>
+        </p:txBody>
+      </p:sp>
+      <p:sp>
+        <p:nvSpPr>
+          <p:cNvPr id="7" name="Foliennummernplatzhalter 6"/>
+          <p:cNvSpPr>
+            <a:spLocks noGrp="1"/>
+          </p:cNvSpPr>
+          <p:nvPr>
+            <p:ph type="sldNum" sz="quarter" idx="5"/>
+          </p:nvPr>
+        </p:nvSpPr>
+        <p:spPr>
+          <a:xfrm>
+            <a:off x="3884613" y="8685213"/>
+            <a:ext cx="2971800" cy="458787"/>
+          </a:xfrm>
+          <a:prstGeom prst="rect">
+            <a:avLst/>
+          </a:prstGeom>
+        </p:spPr>
+        <p:txBody>
+          <a:bodyPr vert="horz" lIns="91440" tIns="45720" rIns="91440" bIns="45720" rtlCol="0" anchor="b"/>
+          <a:lstStyle>
+            <a:lvl1pPr algn="r">
+              <a:defRPr sz="1200"/>
+            </a:lvl1pPr>
+          </a:lstStyle>
+          <a:p>
+            <a:fld id="{31F2B503-182B-4364-98D4-01F22EC42019}" type="slidenum">
+              <a:rPr lang="de-AT" smtClean="0"/>
+              <a:t>‹Nr.›</a:t>
+            </a:fld>
+            <a:endParaRPr lang="de-AT"/>
+          </a:p>
+        </p:txBody>
+      </p:sp>
+    </p:spTree>
+    <p:extLst>
+      <p:ext uri="{BB962C8B-B14F-4D97-AF65-F5344CB8AC3E}">
+        <p14:creationId xmlns:p14="http://schemas.microsoft.com/office/powerpoint/2010/main" val="3154176943"/>
+      </p:ext>
+    </p:extLst>
+  </p:cSld>
+  <p:clrMap bg1="lt1" tx1="dk1" bg2="lt2" tx2="dk2" accent1="accent1" accent2="accent2" accent3="accent3" accent4="accent4" accent5="accent5" accent6="accent6" hlink="hlink" folHlink="folHlink"/>
+  <p:notesStyle>
+    <a:lvl1pPr marL="0" algn="l" defTabSz="914400" rtl="0" eaLnBrk="1" latinLnBrk="0" hangingPunct="1">
+      <a:defRPr sz="1200" kern="1200">
+        <a:solidFill>
+          <a:schemeClr val="tx1"/>
+        </a:solidFill>
+        <a:latin typeface="+mn-lt"/>
+        <a:ea typeface="+mn-ea"/>
+        <a:cs typeface="+mn-cs"/>
+      </a:defRPr>
+    </a:lvl1pPr>
+    <a:lvl2pPr marL="457200" algn="l" defTabSz="914400" rtl="0" eaLnBrk="1" latinLnBrk="0" hangingPunct="1">
+      <a:defRPr sz="1200" kern="1200">
+        <a:solidFill>
+          <a:schemeClr val="tx1"/>
+        </a:solidFill>
+        <a:latin typeface="+mn-lt"/>
+        <a:ea typeface="+mn-ea"/>
+        <a:cs typeface="+mn-cs"/>
+      </a:defRPr>
+    </a:lvl2pPr>
+    <a:lvl3pPr marL="914400" algn="l" defTabSz="914400" rtl="0" eaLnBrk="1" latinLnBrk="0" hangingPunct="1">
+      <a:defRPr sz="1200" kern="1200">
+        <a:solidFill>
+          <a:schemeClr val="tx1"/>
+        </a:solidFill>
+        <a:latin typeface="+mn-lt"/>
+        <a:ea typeface="+mn-ea"/>
+        <a:cs typeface="+mn-cs"/>
+      </a:defRPr>
+    </a:lvl3pPr>
+    <a:lvl4pPr marL="1371600" algn="l" defTabSz="914400" rtl="0" eaLnBrk="1" latinLnBrk="0" hangingPunct="1">
+      <a:defRPr sz="1200" kern="1200">
+        <a:solidFill>
+          <a:schemeClr val="tx1"/>
+        </a:solidFill>
+        <a:latin typeface="+mn-lt"/>
+        <a:ea typeface="+mn-ea"/>
+        <a:cs typeface="+mn-cs"/>
+      </a:defRPr>
+    </a:lvl4pPr>
+    <a:lvl5pPr marL="1828800" algn="l" defTabSz="914400" rtl="0" eaLnBrk="1" latinLnBrk="0" hangingPunct="1">
+      <a:defRPr sz="1200" kern="1200">
+        <a:solidFill>
+          <a:schemeClr val="tx1"/>
+        </a:solidFill>
+        <a:latin typeface="+mn-lt"/>
+        <a:ea typeface="+mn-ea"/>
+        <a:cs typeface="+mn-cs"/>
+      </a:defRPr>
+    </a:lvl5pPr>
+    <a:lvl6pPr marL="2286000" algn="l" defTabSz="914400" rtl="0" eaLnBrk="1" latinLnBrk="0" hangingPunct="1">
+      <a:defRPr sz="1200" kern="1200">
+        <a:solidFill>
+          <a:schemeClr val="tx1"/>
+        </a:solidFill>
+        <a:latin typeface="+mn-lt"/>
+        <a:ea typeface="+mn-ea"/>
+        <a:cs typeface="+mn-cs"/>
+      </a:defRPr>
+    </a:lvl6pPr>
+    <a:lvl7pPr marL="2743200" algn="l" defTabSz="914400" rtl="0" eaLnBrk="1" latinLnBrk="0" hangingPunct="1">
+      <a:defRPr sz="1200" kern="1200">
+        <a:solidFill>
+          <a:schemeClr val="tx1"/>
+        </a:solidFill>
+        <a:latin typeface="+mn-lt"/>
+        <a:ea typeface="+mn-ea"/>
+        <a:cs typeface="+mn-cs"/>
+      </a:defRPr>
+    </a:lvl7pPr>
+    <a:lvl8pPr marL="3200400" algn="l" defTabSz="914400" rtl="0" eaLnBrk="1" latinLnBrk="0" hangingPunct="1">
+      <a:defRPr sz="1200" kern="1200">
+        <a:solidFill>
+          <a:schemeClr val="tx1"/>
+        </a:solidFill>
+        <a:latin typeface="+mn-lt"/>
+        <a:ea typeface="+mn-ea"/>
+        <a:cs typeface="+mn-cs"/>
+      </a:defRPr>
+    </a:lvl8pPr>
+    <a:lvl9pPr marL="3657600" algn="l" defTabSz="914400" rtl="0" eaLnBrk="1" latinLnBrk="0" hangingPunct="1">
+      <a:defRPr sz="1200" kern="1200">
+        <a:solidFill>
+          <a:schemeClr val="tx1"/>
+        </a:solidFill>
+        <a:latin typeface="+mn-lt"/>
+        <a:ea typeface="+mn-ea"/>
+        <a:cs typeface="+mn-cs"/>
+      </a:defRPr>
+    </a:lvl9pPr>
+  </p:notesStyle>
+</p:notesMaster>
+</file>
+
+<file path=ppt/notesSlides/notesSlide1.xml><?xml version="1.0" encoding="utf-8"?>
+<p:notes xmlns:a="http://schemas.openxmlformats.org/drawingml/2006/main" xmlns:r="http://schemas.openxmlformats.org/officeDocument/2006/relationships" xmlns:p="http://schemas.openxmlformats.org/presentationml/2006/main">
+  <p:cSld>
+    <p:spTree>
+      <p:nvGrpSpPr>
+        <p:cNvPr id="1" name=""/>
+        <p:cNvGrpSpPr/>
+        <p:nvPr/>
+      </p:nvGrpSpPr>
+      <p:grpSpPr>
+        <a:xfrm>
+          <a:off x="0" y="0"/>
+          <a:ext cx="0" cy="0"/>
+          <a:chOff x="0" y="0"/>
+          <a:chExt cx="0" cy="0"/>
+        </a:xfrm>
+      </p:grpSpPr>
+      <p:sp>
+        <p:nvSpPr>
+          <p:cNvPr id="2" name="Folienbildplatzhalter 1"/>
+          <p:cNvSpPr>
+            <a:spLocks noGrp="1" noRot="1" noChangeAspect="1"/>
+          </p:cNvSpPr>
+          <p:nvPr>
+            <p:ph type="sldImg"/>
+          </p:nvPr>
+        </p:nvSpPr>
+        <p:spPr/>
+      </p:sp>
+      <p:sp>
+        <p:nvSpPr>
+          <p:cNvPr id="3" name="Notizenplatzhalter 2"/>
+          <p:cNvSpPr>
+            <a:spLocks noGrp="1"/>
+          </p:cNvSpPr>
+          <p:nvPr>
+            <p:ph type="body" idx="1"/>
+          </p:nvPr>
+        </p:nvSpPr>
+        <p:spPr/>
+        <p:txBody>
+          <a:bodyPr/>
+          <a:lstStyle/>
+          <a:p>
+            <a:endParaRPr lang="de-AT" dirty="0"/>
+          </a:p>
+        </p:txBody>
+      </p:sp>
+      <p:sp>
+        <p:nvSpPr>
+          <p:cNvPr id="4" name="Foliennummernplatzhalter 3"/>
+          <p:cNvSpPr>
+            <a:spLocks noGrp="1"/>
+          </p:cNvSpPr>
+          <p:nvPr>
+            <p:ph type="sldNum" sz="quarter" idx="5"/>
+          </p:nvPr>
+        </p:nvSpPr>
+        <p:spPr/>
+        <p:txBody>
+          <a:bodyPr/>
+          <a:lstStyle/>
+          <a:p>
+            <a:fld id="{31F2B503-182B-4364-98D4-01F22EC42019}" type="slidenum">
+              <a:rPr lang="de-AT" smtClean="0"/>
+              <a:t>3</a:t>
+            </a:fld>
+            <a:endParaRPr lang="de-AT"/>
+          </a:p>
+        </p:txBody>
+      </p:sp>
+    </p:spTree>
+    <p:extLst>
+      <p:ext uri="{BB962C8B-B14F-4D97-AF65-F5344CB8AC3E}">
+        <p14:creationId xmlns:p14="http://schemas.microsoft.com/office/powerpoint/2010/main" val="1726871334"/>
+      </p:ext>
+    </p:extLst>
+  </p:cSld>
+  <p:clrMapOvr>
+    <a:masterClrMapping/>
+  </p:clrMapOvr>
+</p:notes>
+</file>
+
 <file path=ppt/slideLayouts/slideLayout1.xml><?xml version="1.0" encoding="utf-8"?>
 <p:sldLayout xmlns:a="http://schemas.openxmlformats.org/drawingml/2006/main" xmlns:r="http://schemas.openxmlformats.org/officeDocument/2006/relationships" xmlns:p="http://schemas.openxmlformats.org/presentationml/2006/main" type="title" preserve="1">
   <p:cSld name="Titelfolie">
@@ -3615,7 +4052,7 @@
           <a:p>
             <a:fld id="{AB4A5B31-C8C7-4C22-B0E9-873766B6517D}" type="datetimeFigureOut">
               <a:rPr lang="de-DE" smtClean="0"/>
-              <a:t>24.03.2026</a:t>
+              <a:t>25.03.2026</a:t>
             </a:fld>
             <a:endParaRPr lang="de-DE"/>
           </a:p>
@@ -3927,7 +4364,7 @@
           <a:p>
             <a:fld id="{AB4A5B31-C8C7-4C22-B0E9-873766B6517D}" type="datetimeFigureOut">
               <a:rPr lang="de-DE" smtClean="0"/>
-              <a:t>24.03.2026</a:t>
+              <a:t>25.03.2026</a:t>
             </a:fld>
             <a:endParaRPr lang="de-DE"/>
           </a:p>
@@ -4149,7 +4586,7 @@
           <a:p>
             <a:fld id="{AB4A5B31-C8C7-4C22-B0E9-873766B6517D}" type="datetimeFigureOut">
               <a:rPr lang="de-DE" smtClean="0"/>
-              <a:t>24.03.2026</a:t>
+              <a:t>25.03.2026</a:t>
             </a:fld>
             <a:endParaRPr lang="de-DE"/>
           </a:p>
@@ -4440,7 +4877,7 @@
           <a:p>
             <a:fld id="{AB4A5B31-C8C7-4C22-B0E9-873766B6517D}" type="datetimeFigureOut">
               <a:rPr lang="de-DE" smtClean="0"/>
-              <a:t>24.03.2026</a:t>
+              <a:t>25.03.2026</a:t>
             </a:fld>
             <a:endParaRPr lang="de-DE"/>
           </a:p>
@@ -4894,7 +5331,7 @@
           <a:p>
             <a:fld id="{AB4A5B31-C8C7-4C22-B0E9-873766B6517D}" type="datetimeFigureOut">
               <a:rPr lang="de-DE" smtClean="0"/>
-              <a:t>24.03.2026</a:t>
+              <a:t>25.03.2026</a:t>
             </a:fld>
             <a:endParaRPr lang="de-DE"/>
           </a:p>
@@ -5470,7 +5907,7 @@
           <a:p>
             <a:fld id="{AB4A5B31-C8C7-4C22-B0E9-873766B6517D}" type="datetimeFigureOut">
               <a:rPr lang="de-DE" smtClean="0"/>
-              <a:t>24.03.2026</a:t>
+              <a:t>25.03.2026</a:t>
             </a:fld>
             <a:endParaRPr lang="de-DE"/>
           </a:p>
@@ -6322,7 +6759,7 @@
           <a:p>
             <a:fld id="{AB4A5B31-C8C7-4C22-B0E9-873766B6517D}" type="datetimeFigureOut">
               <a:rPr lang="de-DE" smtClean="0"/>
-              <a:t>24.03.2026</a:t>
+              <a:t>25.03.2026</a:t>
             </a:fld>
             <a:endParaRPr lang="de-DE"/>
           </a:p>
@@ -6527,7 +6964,7 @@
           <a:p>
             <a:fld id="{AB4A5B31-C8C7-4C22-B0E9-873766B6517D}" type="datetimeFigureOut">
               <a:rPr lang="de-DE" smtClean="0"/>
-              <a:t>24.03.2026</a:t>
+              <a:t>25.03.2026</a:t>
             </a:fld>
             <a:endParaRPr lang="de-DE"/>
           </a:p>
@@ -6741,7 +7178,7 @@
           <a:p>
             <a:fld id="{AB4A5B31-C8C7-4C22-B0E9-873766B6517D}" type="datetimeFigureOut">
               <a:rPr lang="de-DE" smtClean="0"/>
-              <a:t>24.03.2026</a:t>
+              <a:t>25.03.2026</a:t>
             </a:fld>
             <a:endParaRPr lang="de-DE"/>
           </a:p>
@@ -6911,7 +7348,7 @@
           <a:p>
             <a:fld id="{AB4A5B31-C8C7-4C22-B0E9-873766B6517D}" type="datetimeFigureOut">
               <a:rPr lang="de-DE" smtClean="0"/>
-              <a:t>24.03.2026</a:t>
+              <a:t>25.03.2026</a:t>
             </a:fld>
             <a:endParaRPr lang="de-DE"/>
           </a:p>
@@ -7116,7 +7553,7 @@
           <a:p>
             <a:fld id="{AB4A5B31-C8C7-4C22-B0E9-873766B6517D}" type="datetimeFigureOut">
               <a:rPr lang="de-DE" smtClean="0"/>
-              <a:t>24.03.2026</a:t>
+              <a:t>25.03.2026</a:t>
             </a:fld>
             <a:endParaRPr lang="de-DE"/>
           </a:p>
@@ -7396,7 +7833,7 @@
           <a:p>
             <a:fld id="{AB4A5B31-C8C7-4C22-B0E9-873766B6517D}" type="datetimeFigureOut">
               <a:rPr lang="de-DE" smtClean="0"/>
-              <a:t>24.03.2026</a:t>
+              <a:t>25.03.2026</a:t>
             </a:fld>
             <a:endParaRPr lang="de-DE"/>
           </a:p>
@@ -7663,7 +8100,7 @@
           <a:p>
             <a:fld id="{AB4A5B31-C8C7-4C22-B0E9-873766B6517D}" type="datetimeFigureOut">
               <a:rPr lang="de-DE" smtClean="0"/>
-              <a:t>24.03.2026</a:t>
+              <a:t>25.03.2026</a:t>
             </a:fld>
             <a:endParaRPr lang="de-DE"/>
           </a:p>
@@ -8078,7 +8515,7 @@
           <a:p>
             <a:fld id="{AB4A5B31-C8C7-4C22-B0E9-873766B6517D}" type="datetimeFigureOut">
               <a:rPr lang="de-DE" smtClean="0"/>
-              <a:t>24.03.2026</a:t>
+              <a:t>25.03.2026</a:t>
             </a:fld>
             <a:endParaRPr lang="de-DE"/>
           </a:p>
@@ -8226,7 +8663,7 @@
           <a:p>
             <a:fld id="{AB4A5B31-C8C7-4C22-B0E9-873766B6517D}" type="datetimeFigureOut">
               <a:rPr lang="de-DE" smtClean="0"/>
-              <a:t>24.03.2026</a:t>
+              <a:t>25.03.2026</a:t>
             </a:fld>
             <a:endParaRPr lang="de-DE"/>
           </a:p>
@@ -8351,7 +8788,7 @@
           <a:p>
             <a:fld id="{AB4A5B31-C8C7-4C22-B0E9-873766B6517D}" type="datetimeFigureOut">
               <a:rPr lang="de-DE" smtClean="0"/>
-              <a:t>24.03.2026</a:t>
+              <a:t>25.03.2026</a:t>
             </a:fld>
             <a:endParaRPr lang="de-DE"/>
           </a:p>
@@ -8630,7 +9067,7 @@
           <a:p>
             <a:fld id="{AB4A5B31-C8C7-4C22-B0E9-873766B6517D}" type="datetimeFigureOut">
               <a:rPr lang="de-DE" smtClean="0"/>
-              <a:t>24.03.2026</a:t>
+              <a:t>25.03.2026</a:t>
             </a:fld>
             <a:endParaRPr lang="de-DE"/>
           </a:p>
@@ -8942,7 +9379,7 @@
           <a:p>
             <a:fld id="{AB4A5B31-C8C7-4C22-B0E9-873766B6517D}" type="datetimeFigureOut">
               <a:rPr lang="de-DE" smtClean="0"/>
-              <a:t>24.03.2026</a:t>
+              <a:t>25.03.2026</a:t>
             </a:fld>
             <a:endParaRPr lang="de-DE"/>
           </a:p>
@@ -9195,7 +9632,7 @@
           <a:p>
             <a:fld id="{AB4A5B31-C8C7-4C22-B0E9-873766B6517D}" type="datetimeFigureOut">
               <a:rPr lang="de-DE" smtClean="0"/>
-              <a:t>24.03.2026</a:t>
+              <a:t>25.03.2026</a:t>
             </a:fld>
             <a:endParaRPr lang="de-DE"/>
           </a:p>
@@ -9941,10 +10378,10 @@
           <a:lstStyle/>
           <a:p>
             <a:r>
-              <a:rPr lang="de-AT" sz="3000"/>
+              <a:rPr lang="de-AT" sz="3000" dirty="0"/>
               <a:t>Datenmodellierung einer Trafik</a:t>
             </a:r>
-            <a:endParaRPr lang="de-DE" sz="3000"/>
+            <a:endParaRPr lang="de-DE" sz="3000" dirty="0"/>
           </a:p>
         </p:txBody>
       </p:sp>
@@ -9982,10 +10419,10 @@
               </a:lnSpc>
             </a:pPr>
             <a:r>
-              <a:rPr lang="de-AT" sz="2000"/>
+              <a:rPr lang="de-AT" sz="2000" dirty="0"/>
               <a:t>Team: Andreas, Michael, Leonhard</a:t>
             </a:r>
-            <a:endParaRPr lang="de-DE" sz="2000"/>
+            <a:endParaRPr lang="de-DE" sz="2000" dirty="0"/>
           </a:p>
         </p:txBody>
       </p:sp>
@@ -10545,7 +10982,7 @@
           </p:nvPr>
         </p:nvPicPr>
         <p:blipFill>
-          <a:blip r:embed="rId2">
+          <a:blip r:embed="rId3">
             <a:alphaModFix/>
             <a:extLst>
               <a:ext uri="{28A0092B-C50C-407E-A947-70E740481C1C}">
@@ -10602,7 +11039,7 @@
           </p:nvPr>
         </p:nvPicPr>
         <p:blipFill>
-          <a:blip r:embed="rId3">
+          <a:blip r:embed="rId4">
             <a:extLst>
               <a:ext uri="{28A0092B-C50C-407E-A947-70E740481C1C}">
                 <a14:useLocalDpi xmlns:a14="http://schemas.microsoft.com/office/drawing/2010/main" val="0"/>
@@ -10742,7 +11179,7 @@
           </p:nvPr>
         </p:nvPicPr>
         <p:blipFill rotWithShape="1">
-          <a:blip r:embed="rId4">
+          <a:blip r:embed="rId5">
             <a:extLst>
               <a:ext uri="{28A0092B-C50C-407E-A947-70E740481C1C}">
                 <a14:useLocalDpi xmlns:a14="http://schemas.microsoft.com/office/drawing/2010/main" val="0"/>
@@ -10786,7 +11223,7 @@
           </p:nvPr>
         </p:nvPicPr>
         <p:blipFill rotWithShape="1">
-          <a:blip r:embed="rId4">
+          <a:blip r:embed="rId5">
             <a:extLst>
               <a:ext uri="{28A0092B-C50C-407E-A947-70E740481C1C}">
                 <a14:useLocalDpi xmlns:a14="http://schemas.microsoft.com/office/drawing/2010/main" val="0"/>
@@ -10889,7 +11326,7 @@
           </p:nvPr>
         </p:nvPicPr>
         <p:blipFill rotWithShape="1">
-          <a:blip r:embed="rId3">
+          <a:blip r:embed="rId4">
             <a:extLst>
               <a:ext uri="{28A0092B-C50C-407E-A947-70E740481C1C}">
                 <a14:useLocalDpi xmlns:a14="http://schemas.microsoft.com/office/drawing/2010/main" val="0"/>
@@ -10911,10 +11348,10 @@
       </p:pic>
       <p:pic>
         <p:nvPicPr>
-          <p:cNvPr id="6" name="Inhaltsplatzhalter 5">
+          <p:cNvPr id="7" name="Inhaltsplatzhalter 6">
             <a:extLst>
               <a:ext uri="{FF2B5EF4-FFF2-40B4-BE49-F238E27FC236}">
-                <a16:creationId xmlns:a16="http://schemas.microsoft.com/office/drawing/2014/main" id="{7073C52C-E4DA-A562-A5F0-BDDA1FC83806}"/>
+                <a16:creationId xmlns:a16="http://schemas.microsoft.com/office/drawing/2014/main" id="{37783690-F77B-60A6-DEDE-F174EA65B88B}"/>
               </a:ext>
             </a:extLst>
           </p:cNvPr>
@@ -10926,22 +11363,21 @@
           </p:nvPr>
         </p:nvPicPr>
         <p:blipFill>
-          <a:blip r:embed="rId5">
+          <a:blip r:embed="rId6">
             <a:extLst>
               <a:ext uri="{28A0092B-C50C-407E-A947-70E740481C1C}">
                 <a14:useLocalDpi xmlns:a14="http://schemas.microsoft.com/office/drawing/2010/main" val="0"/>
               </a:ext>
             </a:extLst>
           </a:blip>
-          <a:srcRect b="8228"/>
           <a:stretch>
             <a:fillRect/>
           </a:stretch>
         </p:blipFill>
         <p:spPr>
           <a:xfrm>
-            <a:off x="2223432" y="-48601"/>
-            <a:ext cx="10079853" cy="6955200"/>
+            <a:off x="-78130" y="-114874"/>
+            <a:ext cx="12287252" cy="6972874"/>
           </a:xfrm>
           <a:prstGeom prst="rect">
             <a:avLst/>
@@ -11618,4 +12054,319 @@
     </a:ext>
   </a:extLst>
 </a:theme>
+</file>
+
+<file path=ppt/theme/theme2.xml><?xml version="1.0" encoding="utf-8"?>
+<a:theme xmlns:a="http://schemas.openxmlformats.org/drawingml/2006/main" name="Office">
+  <a:themeElements>
+    <a:clrScheme name="Office">
+      <a:dk1>
+        <a:sysClr val="windowText" lastClr="000000"/>
+      </a:dk1>
+      <a:lt1>
+        <a:sysClr val="window" lastClr="FFFFFF"/>
+      </a:lt1>
+      <a:dk2>
+        <a:srgbClr val="0E2841"/>
+      </a:dk2>
+      <a:lt2>
+        <a:srgbClr val="E8E8E8"/>
+      </a:lt2>
+      <a:accent1>
+        <a:srgbClr val="156082"/>
+      </a:accent1>
+      <a:accent2>
+        <a:srgbClr val="E97132"/>
+      </a:accent2>
+      <a:accent3>
+        <a:srgbClr val="196B24"/>
+      </a:accent3>
+      <a:accent4>
+        <a:srgbClr val="0F9ED5"/>
+      </a:accent4>
+      <a:accent5>
+        <a:srgbClr val="A02B93"/>
+      </a:accent5>
+      <a:accent6>
+        <a:srgbClr val="4EA72E"/>
+      </a:accent6>
+      <a:hlink>
+        <a:srgbClr val="467886"/>
+      </a:hlink>
+      <a:folHlink>
+        <a:srgbClr val="96607D"/>
+      </a:folHlink>
+    </a:clrScheme>
+    <a:fontScheme name="Office">
+      <a:majorFont>
+        <a:latin typeface="Aptos Display" panose="02110004020202020204"/>
+        <a:ea typeface=""/>
+        <a:cs typeface=""/>
+        <a:font script="Jpan" typeface="游ゴシック Light"/>
+        <a:font script="Hang" typeface="맑은 고딕"/>
+        <a:font script="Hans" typeface="等线 Light"/>
+        <a:font script="Hant" typeface="新細明體"/>
+        <a:font script="Arab" typeface="Times New Roman"/>
+        <a:font script="Hebr" typeface="Times New Roman"/>
+        <a:font script="Thai" typeface="Angsana New"/>
+        <a:font script="Ethi" typeface="Nyala"/>
+        <a:font script="Beng" typeface="Vrinda"/>
+        <a:font script="Gujr" typeface="Shruti"/>
+        <a:font script="Khmr" typeface="MoolBoran"/>
+        <a:font script="Knda" typeface="Tunga"/>
+        <a:font script="Guru" typeface="Raavi"/>
+        <a:font script="Cans" typeface="Euphemia"/>
+        <a:font script="Cher" typeface="Plantagenet Cherokee"/>
+        <a:font script="Yiii" typeface="Microsoft Yi Baiti"/>
+        <a:font script="Tibt" typeface="Microsoft Himalaya"/>
+        <a:font script="Thaa" typeface="MV Boli"/>
+        <a:font script="Deva" typeface="Mangal"/>
+        <a:font script="Telu" typeface="Gautami"/>
+        <a:font script="Taml" typeface="Latha"/>
+        <a:font script="Syrc" typeface="Estrangelo Edessa"/>
+        <a:font script="Orya" typeface="Kalinga"/>
+        <a:font script="Mlym" typeface="Kartika"/>
+        <a:font script="Laoo" typeface="DokChampa"/>
+        <a:font script="Sinh" typeface="Iskoola Pota"/>
+        <a:font script="Mong" typeface="Mongolian Baiti"/>
+        <a:font script="Viet" typeface="Times New Roman"/>
+        <a:font script="Uigh" typeface="Microsoft Uighur"/>
+        <a:font script="Geor" typeface="Sylfaen"/>
+        <a:font script="Armn" typeface="Arial"/>
+        <a:font script="Bugi" typeface="Leelawadee UI"/>
+        <a:font script="Bopo" typeface="Microsoft JhengHei"/>
+        <a:font script="Java" typeface="Javanese Text"/>
+        <a:font script="Lisu" typeface="Segoe UI"/>
+        <a:font script="Mymr" typeface="Myanmar Text"/>
+        <a:font script="Nkoo" typeface="Ebrima"/>
+        <a:font script="Olck" typeface="Nirmala UI"/>
+        <a:font script="Osma" typeface="Ebrima"/>
+        <a:font script="Phag" typeface="Phagspa"/>
+        <a:font script="Syrn" typeface="Estrangelo Edessa"/>
+        <a:font script="Syrj" typeface="Estrangelo Edessa"/>
+        <a:font script="Syre" typeface="Estrangelo Edessa"/>
+        <a:font script="Sora" typeface="Nirmala UI"/>
+        <a:font script="Tale" typeface="Microsoft Tai Le"/>
+        <a:font script="Talu" typeface="Microsoft New Tai Lue"/>
+        <a:font script="Tfng" typeface="Ebrima"/>
+      </a:majorFont>
+      <a:minorFont>
+        <a:latin typeface="Aptos" panose="02110004020202020204"/>
+        <a:ea typeface=""/>
+        <a:cs typeface=""/>
+        <a:font script="Jpan" typeface="游ゴシック"/>
+        <a:font script="Hang" typeface="맑은 고딕"/>
+        <a:font script="Hans" typeface="等线"/>
+        <a:font script="Hant" typeface="新細明體"/>
+        <a:font script="Arab" typeface="Arial"/>
+        <a:font script="Hebr" typeface="Arial"/>
+        <a:font script="Thai" typeface="Cordia New"/>
+        <a:font script="Ethi" typeface="Nyala"/>
+        <a:font script="Beng" typeface="Vrinda"/>
+        <a:font script="Gujr" typeface="Shruti"/>
+        <a:font script="Khmr" typeface="DaunPenh"/>
+        <a:font script="Knda" typeface="Tunga"/>
+        <a:font script="Guru" typeface="Raavi"/>
+        <a:font script="Cans" typeface="Euphemia"/>
+        <a:font script="Cher" typeface="Plantagenet Cherokee"/>
+        <a:font script="Yiii" typeface="Microsoft Yi Baiti"/>
+        <a:font script="Tibt" typeface="Microsoft Himalaya"/>
+        <a:font script="Thaa" typeface="MV Boli"/>
+        <a:font script="Deva" typeface="Mangal"/>
+        <a:font script="Telu" typeface="Gautami"/>
+        <a:font script="Taml" typeface="Latha"/>
+        <a:font script="Syrc" typeface="Estrangelo Edessa"/>
+        <a:font script="Orya" typeface="Kalinga"/>
+        <a:font script="Mlym" typeface="Kartika"/>
+        <a:font script="Laoo" typeface="DokChampa"/>
+        <a:font script="Sinh" typeface="Iskoola Pota"/>
+        <a:font script="Mong" typeface="Mongolian Baiti"/>
+        <a:font script="Viet" typeface="Arial"/>
+        <a:font script="Uigh" typeface="Microsoft Uighur"/>
+        <a:font script="Geor" typeface="Sylfaen"/>
+        <a:font script="Armn" typeface="Arial"/>
+        <a:font script="Bugi" typeface="Leelawadee UI"/>
+        <a:font script="Bopo" typeface="Microsoft JhengHei"/>
+        <a:font script="Java" typeface="Javanese Text"/>
+        <a:font script="Lisu" typeface="Segoe UI"/>
+        <a:font script="Mymr" typeface="Myanmar Text"/>
+        <a:font script="Nkoo" typeface="Ebrima"/>
+        <a:font script="Olck" typeface="Nirmala UI"/>
+        <a:font script="Osma" typeface="Ebrima"/>
+        <a:font script="Phag" typeface="Phagspa"/>
+        <a:font script="Syrn" typeface="Estrangelo Edessa"/>
+        <a:font script="Syrj" typeface="Estrangelo Edessa"/>
+        <a:font script="Syre" typeface="Estrangelo Edessa"/>
+        <a:font script="Sora" typeface="Nirmala UI"/>
+        <a:font script="Tale" typeface="Microsoft Tai Le"/>
+        <a:font script="Talu" typeface="Microsoft New Tai Lue"/>
+        <a:font script="Tfng" typeface="Ebrima"/>
+      </a:minorFont>
+    </a:fontScheme>
+    <a:fmtScheme name="Office">
+      <a:fillStyleLst>
+        <a:solidFill>
+          <a:schemeClr val="phClr"/>
+        </a:solidFill>
+        <a:gradFill rotWithShape="1">
+          <a:gsLst>
+            <a:gs pos="0">
+              <a:schemeClr val="phClr">
+                <a:lumMod val="110000"/>
+                <a:satMod val="105000"/>
+                <a:tint val="67000"/>
+              </a:schemeClr>
+            </a:gs>
+            <a:gs pos="50000">
+              <a:schemeClr val="phClr">
+                <a:lumMod val="105000"/>
+                <a:satMod val="103000"/>
+                <a:tint val="73000"/>
+              </a:schemeClr>
+            </a:gs>
+            <a:gs pos="100000">
+              <a:schemeClr val="phClr">
+                <a:lumMod val="105000"/>
+                <a:satMod val="109000"/>
+                <a:tint val="81000"/>
+              </a:schemeClr>
+            </a:gs>
+          </a:gsLst>
+          <a:lin ang="5400000" scaled="0"/>
+        </a:gradFill>
+        <a:gradFill rotWithShape="1">
+          <a:gsLst>
+            <a:gs pos="0">
+              <a:schemeClr val="phClr">
+                <a:satMod val="103000"/>
+                <a:lumMod val="102000"/>
+                <a:tint val="94000"/>
+              </a:schemeClr>
+            </a:gs>
+            <a:gs pos="50000">
+              <a:schemeClr val="phClr">
+                <a:satMod val="110000"/>
+                <a:lumMod val="100000"/>
+                <a:shade val="100000"/>
+              </a:schemeClr>
+            </a:gs>
+            <a:gs pos="100000">
+              <a:schemeClr val="phClr">
+                <a:lumMod val="99000"/>
+                <a:satMod val="120000"/>
+                <a:shade val="78000"/>
+              </a:schemeClr>
+            </a:gs>
+          </a:gsLst>
+          <a:lin ang="5400000" scaled="0"/>
+        </a:gradFill>
+      </a:fillStyleLst>
+      <a:lnStyleLst>
+        <a:ln w="12700" cap="flat" cmpd="sng" algn="ctr">
+          <a:solidFill>
+            <a:schemeClr val="phClr"/>
+          </a:solidFill>
+          <a:prstDash val="solid"/>
+          <a:miter lim="800000"/>
+        </a:ln>
+        <a:ln w="19050" cap="flat" cmpd="sng" algn="ctr">
+          <a:solidFill>
+            <a:schemeClr val="phClr"/>
+          </a:solidFill>
+          <a:prstDash val="solid"/>
+          <a:miter lim="800000"/>
+        </a:ln>
+        <a:ln w="25400" cap="flat" cmpd="sng" algn="ctr">
+          <a:solidFill>
+            <a:schemeClr val="phClr"/>
+          </a:solidFill>
+          <a:prstDash val="solid"/>
+          <a:miter lim="800000"/>
+        </a:ln>
+      </a:lnStyleLst>
+      <a:effectStyleLst>
+        <a:effectStyle>
+          <a:effectLst/>
+        </a:effectStyle>
+        <a:effectStyle>
+          <a:effectLst/>
+        </a:effectStyle>
+        <a:effectStyle>
+          <a:effectLst>
+            <a:outerShdw blurRad="57150" dist="19050" dir="5400000" algn="ctr" rotWithShape="0">
+              <a:srgbClr val="000000">
+                <a:alpha val="63000"/>
+              </a:srgbClr>
+            </a:outerShdw>
+          </a:effectLst>
+        </a:effectStyle>
+      </a:effectStyleLst>
+      <a:bgFillStyleLst>
+        <a:solidFill>
+          <a:schemeClr val="phClr"/>
+        </a:solidFill>
+        <a:solidFill>
+          <a:schemeClr val="phClr">
+            <a:tint val="95000"/>
+            <a:satMod val="170000"/>
+          </a:schemeClr>
+        </a:solidFill>
+        <a:gradFill rotWithShape="1">
+          <a:gsLst>
+            <a:gs pos="0">
+              <a:schemeClr val="phClr">
+                <a:tint val="93000"/>
+                <a:satMod val="150000"/>
+                <a:shade val="98000"/>
+                <a:lumMod val="102000"/>
+              </a:schemeClr>
+            </a:gs>
+            <a:gs pos="50000">
+              <a:schemeClr val="phClr">
+                <a:tint val="98000"/>
+                <a:satMod val="130000"/>
+                <a:shade val="90000"/>
+                <a:lumMod val="103000"/>
+              </a:schemeClr>
+            </a:gs>
+            <a:gs pos="100000">
+              <a:schemeClr val="phClr">
+                <a:shade val="63000"/>
+                <a:satMod val="120000"/>
+              </a:schemeClr>
+            </a:gs>
+          </a:gsLst>
+          <a:lin ang="5400000" scaled="0"/>
+        </a:gradFill>
+      </a:bgFillStyleLst>
+    </a:fmtScheme>
+  </a:themeElements>
+  <a:objectDefaults>
+    <a:lnDef>
+      <a:spPr/>
+      <a:bodyPr/>
+      <a:lstStyle/>
+      <a:style>
+        <a:lnRef idx="2">
+          <a:schemeClr val="accent1"/>
+        </a:lnRef>
+        <a:fillRef idx="0">
+          <a:schemeClr val="accent1"/>
+        </a:fillRef>
+        <a:effectRef idx="1">
+          <a:schemeClr val="accent1"/>
+        </a:effectRef>
+        <a:fontRef idx="minor">
+          <a:schemeClr val="tx1"/>
+        </a:fontRef>
+      </a:style>
+    </a:lnDef>
+  </a:objectDefaults>
+  <a:extraClrSchemeLst/>
+  <a:extLst>
+    <a:ext uri="{05A4C25C-085E-4340-85A3-A5531E510DB2}">
+      <thm15:themeFamily xmlns:thm15="http://schemas.microsoft.com/office/thememl/2012/main" name="Office Theme" id="{2E142A2C-CD16-42D6-873A-C26D2A0506FA}" vid="{1BDDFF52-6CD6-40A5-AB3C-68EB2F1E4D0A}"/>
+    </a:ext>
+  </a:extLst>
+</a:theme>
 </file>
</xml_diff>

<commit_message>
projekt passt 1 commit muss reichen
</commit_message>
<xml_diff>
--- a/docs/Präsentation1803.pptx
+++ b/docs/Präsentation1803.pptx
@@ -3615,7 +3615,7 @@
           <a:p>
             <a:fld id="{AB4A5B31-C8C7-4C22-B0E9-873766B6517D}" type="datetimeFigureOut">
               <a:rPr lang="de-DE" smtClean="0"/>
-              <a:t>24.03.2026</a:t>
+              <a:t>25.03.2026</a:t>
             </a:fld>
             <a:endParaRPr lang="de-DE"/>
           </a:p>
@@ -3927,7 +3927,7 @@
           <a:p>
             <a:fld id="{AB4A5B31-C8C7-4C22-B0E9-873766B6517D}" type="datetimeFigureOut">
               <a:rPr lang="de-DE" smtClean="0"/>
-              <a:t>24.03.2026</a:t>
+              <a:t>25.03.2026</a:t>
             </a:fld>
             <a:endParaRPr lang="de-DE"/>
           </a:p>
@@ -4149,7 +4149,7 @@
           <a:p>
             <a:fld id="{AB4A5B31-C8C7-4C22-B0E9-873766B6517D}" type="datetimeFigureOut">
               <a:rPr lang="de-DE" smtClean="0"/>
-              <a:t>24.03.2026</a:t>
+              <a:t>25.03.2026</a:t>
             </a:fld>
             <a:endParaRPr lang="de-DE"/>
           </a:p>
@@ -4440,7 +4440,7 @@
           <a:p>
             <a:fld id="{AB4A5B31-C8C7-4C22-B0E9-873766B6517D}" type="datetimeFigureOut">
               <a:rPr lang="de-DE" smtClean="0"/>
-              <a:t>24.03.2026</a:t>
+              <a:t>25.03.2026</a:t>
             </a:fld>
             <a:endParaRPr lang="de-DE"/>
           </a:p>
@@ -4894,7 +4894,7 @@
           <a:p>
             <a:fld id="{AB4A5B31-C8C7-4C22-B0E9-873766B6517D}" type="datetimeFigureOut">
               <a:rPr lang="de-DE" smtClean="0"/>
-              <a:t>24.03.2026</a:t>
+              <a:t>25.03.2026</a:t>
             </a:fld>
             <a:endParaRPr lang="de-DE"/>
           </a:p>
@@ -5470,7 +5470,7 @@
           <a:p>
             <a:fld id="{AB4A5B31-C8C7-4C22-B0E9-873766B6517D}" type="datetimeFigureOut">
               <a:rPr lang="de-DE" smtClean="0"/>
-              <a:t>24.03.2026</a:t>
+              <a:t>25.03.2026</a:t>
             </a:fld>
             <a:endParaRPr lang="de-DE"/>
           </a:p>
@@ -6322,7 +6322,7 @@
           <a:p>
             <a:fld id="{AB4A5B31-C8C7-4C22-B0E9-873766B6517D}" type="datetimeFigureOut">
               <a:rPr lang="de-DE" smtClean="0"/>
-              <a:t>24.03.2026</a:t>
+              <a:t>25.03.2026</a:t>
             </a:fld>
             <a:endParaRPr lang="de-DE"/>
           </a:p>
@@ -6527,7 +6527,7 @@
           <a:p>
             <a:fld id="{AB4A5B31-C8C7-4C22-B0E9-873766B6517D}" type="datetimeFigureOut">
               <a:rPr lang="de-DE" smtClean="0"/>
-              <a:t>24.03.2026</a:t>
+              <a:t>25.03.2026</a:t>
             </a:fld>
             <a:endParaRPr lang="de-DE"/>
           </a:p>
@@ -6741,7 +6741,7 @@
           <a:p>
             <a:fld id="{AB4A5B31-C8C7-4C22-B0E9-873766B6517D}" type="datetimeFigureOut">
               <a:rPr lang="de-DE" smtClean="0"/>
-              <a:t>24.03.2026</a:t>
+              <a:t>25.03.2026</a:t>
             </a:fld>
             <a:endParaRPr lang="de-DE"/>
           </a:p>
@@ -6911,7 +6911,7 @@
           <a:p>
             <a:fld id="{AB4A5B31-C8C7-4C22-B0E9-873766B6517D}" type="datetimeFigureOut">
               <a:rPr lang="de-DE" smtClean="0"/>
-              <a:t>24.03.2026</a:t>
+              <a:t>25.03.2026</a:t>
             </a:fld>
             <a:endParaRPr lang="de-DE"/>
           </a:p>
@@ -7116,7 +7116,7 @@
           <a:p>
             <a:fld id="{AB4A5B31-C8C7-4C22-B0E9-873766B6517D}" type="datetimeFigureOut">
               <a:rPr lang="de-DE" smtClean="0"/>
-              <a:t>24.03.2026</a:t>
+              <a:t>25.03.2026</a:t>
             </a:fld>
             <a:endParaRPr lang="de-DE"/>
           </a:p>
@@ -7396,7 +7396,7 @@
           <a:p>
             <a:fld id="{AB4A5B31-C8C7-4C22-B0E9-873766B6517D}" type="datetimeFigureOut">
               <a:rPr lang="de-DE" smtClean="0"/>
-              <a:t>24.03.2026</a:t>
+              <a:t>25.03.2026</a:t>
             </a:fld>
             <a:endParaRPr lang="de-DE"/>
           </a:p>
@@ -7663,7 +7663,7 @@
           <a:p>
             <a:fld id="{AB4A5B31-C8C7-4C22-B0E9-873766B6517D}" type="datetimeFigureOut">
               <a:rPr lang="de-DE" smtClean="0"/>
-              <a:t>24.03.2026</a:t>
+              <a:t>25.03.2026</a:t>
             </a:fld>
             <a:endParaRPr lang="de-DE"/>
           </a:p>
@@ -8078,7 +8078,7 @@
           <a:p>
             <a:fld id="{AB4A5B31-C8C7-4C22-B0E9-873766B6517D}" type="datetimeFigureOut">
               <a:rPr lang="de-DE" smtClean="0"/>
-              <a:t>24.03.2026</a:t>
+              <a:t>25.03.2026</a:t>
             </a:fld>
             <a:endParaRPr lang="de-DE"/>
           </a:p>
@@ -8226,7 +8226,7 @@
           <a:p>
             <a:fld id="{AB4A5B31-C8C7-4C22-B0E9-873766B6517D}" type="datetimeFigureOut">
               <a:rPr lang="de-DE" smtClean="0"/>
-              <a:t>24.03.2026</a:t>
+              <a:t>25.03.2026</a:t>
             </a:fld>
             <a:endParaRPr lang="de-DE"/>
           </a:p>
@@ -8351,7 +8351,7 @@
           <a:p>
             <a:fld id="{AB4A5B31-C8C7-4C22-B0E9-873766B6517D}" type="datetimeFigureOut">
               <a:rPr lang="de-DE" smtClean="0"/>
-              <a:t>24.03.2026</a:t>
+              <a:t>25.03.2026</a:t>
             </a:fld>
             <a:endParaRPr lang="de-DE"/>
           </a:p>
@@ -8630,7 +8630,7 @@
           <a:p>
             <a:fld id="{AB4A5B31-C8C7-4C22-B0E9-873766B6517D}" type="datetimeFigureOut">
               <a:rPr lang="de-DE" smtClean="0"/>
-              <a:t>24.03.2026</a:t>
+              <a:t>25.03.2026</a:t>
             </a:fld>
             <a:endParaRPr lang="de-DE"/>
           </a:p>
@@ -8942,7 +8942,7 @@
           <a:p>
             <a:fld id="{AB4A5B31-C8C7-4C22-B0E9-873766B6517D}" type="datetimeFigureOut">
               <a:rPr lang="de-DE" smtClean="0"/>
-              <a:t>24.03.2026</a:t>
+              <a:t>25.03.2026</a:t>
             </a:fld>
             <a:endParaRPr lang="de-DE"/>
           </a:p>
@@ -9195,7 +9195,7 @@
           <a:p>
             <a:fld id="{AB4A5B31-C8C7-4C22-B0E9-873766B6517D}" type="datetimeFigureOut">
               <a:rPr lang="de-DE" smtClean="0"/>
-              <a:t>24.03.2026</a:t>
+              <a:t>25.03.2026</a:t>
             </a:fld>
             <a:endParaRPr lang="de-DE"/>
           </a:p>
@@ -10940,8 +10940,8 @@
         </p:blipFill>
         <p:spPr>
           <a:xfrm>
-            <a:off x="2223432" y="-48601"/>
-            <a:ext cx="10079853" cy="6955200"/>
+            <a:off x="2596444" y="-48601"/>
+            <a:ext cx="9595556" cy="6955200"/>
           </a:xfrm>
           <a:prstGeom prst="rect">
             <a:avLst/>

</xml_diff>